<commit_message>
docs: update the presentation slide version 2
</commit_message>
<xml_diff>
--- a/docs/Presentation/HomeLodge_PSM1_v2.pptx
+++ b/docs/Presentation/HomeLodge_PSM1_v2.pptx
@@ -5894,7 +5894,7 @@
                     <a:p>
                       <a:pPr algn="l"/>
                       <a:r>
-                        <a:rPr sz="1300" b="1">
+                        <a:rPr sz="1300" b="1" dirty="0">
                           <a:solidFill>
                             <a:srgbClr val="FFFFFF"/>
                           </a:solidFill>
@@ -5916,7 +5916,7 @@
                     <a:p>
                       <a:pPr algn="ctr"/>
                       <a:r>
-                        <a:rPr sz="1300" b="1">
+                        <a:rPr sz="1300" b="1" dirty="0">
                           <a:solidFill>
                             <a:srgbClr val="FFFFFF"/>
                           </a:solidFill>
@@ -7035,7 +7035,7 @@
                     <a:p>
                       <a:pPr algn="ctr"/>
                       <a:r>
-                        <a:rPr sz="1200" b="1">
+                        <a:rPr sz="1200" b="1" dirty="0">
                           <a:solidFill>
                             <a:srgbClr val="007000"/>
                           </a:solidFill>
@@ -8483,307 +8483,6 @@
       </p:sp>
       <p:sp>
         <p:nvSpPr>
-          <p:cNvPr id="10" name="Content Placeholder 4">
-            <a:extLst>
-              <a:ext uri="{FF2B5EF4-FFF2-40B4-BE49-F238E27FC236}">
-                <a16:creationId xmlns:a16="http://schemas.microsoft.com/office/drawing/2014/main" id="{465A0785-7D50-B448-960D-9DD2EFFBDD5A}"/>
-              </a:ext>
-            </a:extLst>
-          </p:cNvPr>
-          <p:cNvSpPr txBox="1">
-            <a:spLocks noChangeArrowheads="1"/>
-          </p:cNvSpPr>
-          <p:nvPr/>
-        </p:nvSpPr>
-        <p:spPr bwMode="auto">
-          <a:xfrm>
-            <a:off x="1452562" y="5724528"/>
-            <a:ext cx="7045325" cy="566738"/>
-          </a:xfrm>
-          <a:prstGeom prst="rect">
-            <a:avLst/>
-          </a:prstGeom>
-          <a:noFill/>
-          <a:ln>
-            <a:noFill/>
-          </a:ln>
-          <a:extLst>
-            <a:ext uri="{909E8E84-426E-40DD-AFC4-6F175D3DCCD1}">
-              <a14:hiddenFill xmlns:a14="http://schemas.microsoft.com/office/drawing/2010/main">
-                <a:solidFill>
-                  <a:srgbClr val="FFFFFF"/>
-                </a:solidFill>
-              </a14:hiddenFill>
-            </a:ext>
-            <a:ext uri="{91240B29-F687-4F45-9708-019B960494DF}">
-              <a14:hiddenLine xmlns:a14="http://schemas.microsoft.com/office/drawing/2010/main" w="9525">
-                <a:solidFill>
-                  <a:srgbClr val="000000"/>
-                </a:solidFill>
-                <a:miter lim="800000"/>
-                <a:headEnd/>
-                <a:tailEnd/>
-              </a14:hiddenLine>
-            </a:ext>
-          </a:extLst>
-        </p:spPr>
-        <p:txBody>
-          <a:bodyPr vert="horz" wrap="square" lIns="91440" tIns="45720" rIns="91440" bIns="45720" numCol="1" anchor="t" anchorCtr="0" compatLnSpc="1">
-            <a:prstTxWarp prst="textNoShape">
-              <a:avLst/>
-            </a:prstTxWarp>
-          </a:bodyPr>
-          <a:lstStyle>
-            <a:lvl1pPr marL="228600" indent="-228600" algn="l" rtl="0" eaLnBrk="0" fontAlgn="base" hangingPunct="0">
-              <a:lnSpc>
-                <a:spcPct val="90000"/>
-              </a:lnSpc>
-              <a:spcBef>
-                <a:spcPts val="1000"/>
-              </a:spcBef>
-              <a:spcAft>
-                <a:spcPct val="0"/>
-              </a:spcAft>
-              <a:buFont typeface="Arial" panose="020B0604020202020204" pitchFamily="34" charset="0"/>
-              <a:buChar char="•"/>
-              <a:defRPr sz="2800" kern="1200">
-                <a:solidFill>
-                  <a:schemeClr val="tx1"/>
-                </a:solidFill>
-                <a:latin typeface="+mn-lt"/>
-                <a:ea typeface="+mn-ea"/>
-                <a:cs typeface="+mn-cs"/>
-              </a:defRPr>
-            </a:lvl1pPr>
-            <a:lvl2pPr marL="685800" indent="-228600" algn="l" rtl="0" eaLnBrk="0" fontAlgn="base" hangingPunct="0">
-              <a:lnSpc>
-                <a:spcPct val="90000"/>
-              </a:lnSpc>
-              <a:spcBef>
-                <a:spcPts val="500"/>
-              </a:spcBef>
-              <a:spcAft>
-                <a:spcPct val="0"/>
-              </a:spcAft>
-              <a:buFont typeface="Arial" panose="020B0604020202020204" pitchFamily="34" charset="0"/>
-              <a:buChar char="•"/>
-              <a:defRPr sz="2400" kern="1200">
-                <a:solidFill>
-                  <a:schemeClr val="tx1"/>
-                </a:solidFill>
-                <a:latin typeface="+mn-lt"/>
-                <a:ea typeface="+mn-ea"/>
-                <a:cs typeface="+mn-cs"/>
-              </a:defRPr>
-            </a:lvl2pPr>
-            <a:lvl3pPr marL="1143000" indent="-228600" algn="l" rtl="0" eaLnBrk="0" fontAlgn="base" hangingPunct="0">
-              <a:lnSpc>
-                <a:spcPct val="90000"/>
-              </a:lnSpc>
-              <a:spcBef>
-                <a:spcPts val="500"/>
-              </a:spcBef>
-              <a:spcAft>
-                <a:spcPct val="0"/>
-              </a:spcAft>
-              <a:buFont typeface="Arial" panose="020B0604020202020204" pitchFamily="34" charset="0"/>
-              <a:buChar char="•"/>
-              <a:defRPr sz="2000" kern="1200">
-                <a:solidFill>
-                  <a:schemeClr val="tx1"/>
-                </a:solidFill>
-                <a:latin typeface="+mn-lt"/>
-                <a:ea typeface="+mn-ea"/>
-                <a:cs typeface="+mn-cs"/>
-              </a:defRPr>
-            </a:lvl3pPr>
-            <a:lvl4pPr marL="1600200" indent="-228600" algn="l" rtl="0" eaLnBrk="0" fontAlgn="base" hangingPunct="0">
-              <a:lnSpc>
-                <a:spcPct val="90000"/>
-              </a:lnSpc>
-              <a:spcBef>
-                <a:spcPts val="500"/>
-              </a:spcBef>
-              <a:spcAft>
-                <a:spcPct val="0"/>
-              </a:spcAft>
-              <a:buFont typeface="Arial" panose="020B0604020202020204" pitchFamily="34" charset="0"/>
-              <a:buChar char="•"/>
-              <a:defRPr kern="1200">
-                <a:solidFill>
-                  <a:schemeClr val="tx1"/>
-                </a:solidFill>
-                <a:latin typeface="+mn-lt"/>
-                <a:ea typeface="+mn-ea"/>
-                <a:cs typeface="+mn-cs"/>
-              </a:defRPr>
-            </a:lvl4pPr>
-            <a:lvl5pPr marL="2057400" indent="-228600" algn="l" rtl="0" eaLnBrk="0" fontAlgn="base" hangingPunct="0">
-              <a:lnSpc>
-                <a:spcPct val="90000"/>
-              </a:lnSpc>
-              <a:spcBef>
-                <a:spcPts val="500"/>
-              </a:spcBef>
-              <a:spcAft>
-                <a:spcPct val="0"/>
-              </a:spcAft>
-              <a:buFont typeface="Arial" panose="020B0604020202020204" pitchFamily="34" charset="0"/>
-              <a:buChar char="•"/>
-              <a:defRPr kern="1200">
-                <a:solidFill>
-                  <a:schemeClr val="tx1"/>
-                </a:solidFill>
-                <a:latin typeface="+mn-lt"/>
-                <a:ea typeface="+mn-ea"/>
-                <a:cs typeface="+mn-cs"/>
-              </a:defRPr>
-            </a:lvl5pPr>
-            <a:lvl6pPr marL="2514600" indent="-228600" algn="l" defTabSz="914400" rtl="0" eaLnBrk="1" latinLnBrk="0" hangingPunct="1">
-              <a:lnSpc>
-                <a:spcPct val="90000"/>
-              </a:lnSpc>
-              <a:spcBef>
-                <a:spcPts val="500"/>
-              </a:spcBef>
-              <a:buFont typeface="Arial" panose="020B0604020202020204" pitchFamily="34" charset="0"/>
-              <a:buChar char="•"/>
-              <a:defRPr sz="1800" kern="1200">
-                <a:solidFill>
-                  <a:schemeClr val="tx1"/>
-                </a:solidFill>
-                <a:latin typeface="+mn-lt"/>
-                <a:ea typeface="+mn-ea"/>
-                <a:cs typeface="+mn-cs"/>
-              </a:defRPr>
-            </a:lvl6pPr>
-            <a:lvl7pPr marL="2971800" indent="-228600" algn="l" defTabSz="914400" rtl="0" eaLnBrk="1" latinLnBrk="0" hangingPunct="1">
-              <a:lnSpc>
-                <a:spcPct val="90000"/>
-              </a:lnSpc>
-              <a:spcBef>
-                <a:spcPts val="500"/>
-              </a:spcBef>
-              <a:buFont typeface="Arial" panose="020B0604020202020204" pitchFamily="34" charset="0"/>
-              <a:buChar char="•"/>
-              <a:defRPr sz="1800" kern="1200">
-                <a:solidFill>
-                  <a:schemeClr val="tx1"/>
-                </a:solidFill>
-                <a:latin typeface="+mn-lt"/>
-                <a:ea typeface="+mn-ea"/>
-                <a:cs typeface="+mn-cs"/>
-              </a:defRPr>
-            </a:lvl7pPr>
-            <a:lvl8pPr marL="3429000" indent="-228600" algn="l" defTabSz="914400" rtl="0" eaLnBrk="1" latinLnBrk="0" hangingPunct="1">
-              <a:lnSpc>
-                <a:spcPct val="90000"/>
-              </a:lnSpc>
-              <a:spcBef>
-                <a:spcPts val="500"/>
-              </a:spcBef>
-              <a:buFont typeface="Arial" panose="020B0604020202020204" pitchFamily="34" charset="0"/>
-              <a:buChar char="•"/>
-              <a:defRPr sz="1800" kern="1200">
-                <a:solidFill>
-                  <a:schemeClr val="tx1"/>
-                </a:solidFill>
-                <a:latin typeface="+mn-lt"/>
-                <a:ea typeface="+mn-ea"/>
-                <a:cs typeface="+mn-cs"/>
-              </a:defRPr>
-            </a:lvl8pPr>
-            <a:lvl9pPr marL="3886200" indent="-228600" algn="l" defTabSz="914400" rtl="0" eaLnBrk="1" latinLnBrk="0" hangingPunct="1">
-              <a:lnSpc>
-                <a:spcPct val="90000"/>
-              </a:lnSpc>
-              <a:spcBef>
-                <a:spcPts val="500"/>
-              </a:spcBef>
-              <a:buFont typeface="Arial" panose="020B0604020202020204" pitchFamily="34" charset="0"/>
-              <a:buChar char="•"/>
-              <a:defRPr sz="1800" kern="1200">
-                <a:solidFill>
-                  <a:schemeClr val="tx1"/>
-                </a:solidFill>
-                <a:latin typeface="+mn-lt"/>
-                <a:ea typeface="+mn-ea"/>
-                <a:cs typeface="+mn-cs"/>
-              </a:defRPr>
-            </a:lvl9pPr>
-          </a:lstStyle>
-          <a:p>
-            <a:pPr marL="0" indent="0" algn="ctr" defTabSz="914400" eaLnBrk="1" hangingPunct="1">
-              <a:buFont typeface="Arial" panose="020B0604020202020204" pitchFamily="34" charset="0"/>
-              <a:buNone/>
-            </a:pPr>
-            <a:r>
-              <a:rPr lang="en-US" altLang="en-US" sz="2400" dirty="0">
-                <a:solidFill/>
-                <a:latin typeface="Microsoft Sans Serif" panose="020B0604020202020204" pitchFamily="34" charset="0"/>
-                <a:cs typeface="Microsoft Sans Serif" panose="020B0604020202020204" pitchFamily="34" charset="0"/>
-              </a:rPr>
-              <a:t>Figure: Use this label for each figure</a:t>
-            </a:r>
-          </a:p>
-        </p:txBody>
-      </p:sp>
-      <p:sp>
-        <p:nvSpPr>
-          <p:cNvPr id="4" name="Rectangle 3">
-            <a:extLst>
-              <a:ext uri="{FF2B5EF4-FFF2-40B4-BE49-F238E27FC236}">
-                <a16:creationId xmlns:a16="http://schemas.microsoft.com/office/drawing/2014/main" id="{A910E3DF-3285-8944-A43C-3260C04F0830}"/>
-              </a:ext>
-            </a:extLst>
-          </p:cNvPr>
-          <p:cNvSpPr/>
-          <p:nvPr/>
-        </p:nvSpPr>
-        <p:spPr>
-          <a:xfrm>
-            <a:off x="2128603" y="3229841"/>
-            <a:ext cx="5351489" cy="2282409"/>
-          </a:xfrm>
-          <a:prstGeom prst="rect">
-            <a:avLst/>
-          </a:prstGeom>
-          <a:noFill/>
-          <a:ln>
-            <a:solidFill>
-              <a:schemeClr val="bg1">
-                <a:lumMod val="50000"/>
-              </a:schemeClr>
-            </a:solidFill>
-          </a:ln>
-        </p:spPr>
-        <p:style>
-          <a:lnRef idx="2">
-            <a:schemeClr val="accent1">
-              <a:shade val="50000"/>
-            </a:schemeClr>
-          </a:lnRef>
-          <a:fillRef idx="1">
-            <a:schemeClr val="accent1"/>
-          </a:fillRef>
-          <a:effectRef idx="0">
-            <a:schemeClr val="accent1"/>
-          </a:effectRef>
-          <a:fontRef idx="minor">
-            <a:schemeClr val="lt1"/>
-          </a:fontRef>
-        </p:style>
-        <p:txBody>
-          <a:bodyPr rtlCol="0" anchor="ctr"/>
-          <a:lstStyle/>
-          <a:p>
-            <a:pPr algn="ctr"/>
-            <a:endParaRPr lang="en-US"/>
-          </a:p>
-        </p:txBody>
-      </p:sp>
-      <p:sp>
-        <p:nvSpPr>
           <p:cNvPr id="11" name="Content Placeholder 2">
             <a:extLst>
               <a:ext uri="{FF2B5EF4-FFF2-40B4-BE49-F238E27FC236}">
@@ -8800,8 +8499,8 @@
         </p:nvSpPr>
         <p:spPr>
           <a:xfrm>
-            <a:off x="1485900" y="1825625"/>
-            <a:ext cx="7029450" cy="1191938"/>
+            <a:off x="760942" y="1825626"/>
+            <a:ext cx="7029450" cy="4444999"/>
           </a:xfrm>
         </p:spPr>
         <p:txBody>
@@ -8817,7 +8516,7 @@
               </a:spcAft>
             </a:pPr>
             <a:r>
-              <a:rPr sz="1600" b="1" i="0">
+              <a:rPr sz="1600" b="1" i="0" dirty="0">
                 <a:solidFill>
                   <a:srgbClr val="761D3E"/>
                 </a:solidFill>
@@ -8832,7 +8531,7 @@
               </a:spcBef>
             </a:pPr>
             <a:r>
-              <a:rPr sz="1500" b="0" i="0">
+              <a:rPr sz="1500" b="0" i="0" dirty="0">
                 <a:solidFill>
                   <a:srgbClr val="1A1A1A"/>
                 </a:solidFill>
@@ -8847,7 +8546,7 @@
               </a:spcBef>
             </a:pPr>
             <a:r>
-              <a:rPr sz="1500" b="0" i="0">
+              <a:rPr sz="1500" b="0" i="0" dirty="0">
                 <a:solidFill>
                   <a:srgbClr val="1A1A1A"/>
                 </a:solidFill>
@@ -8861,7 +8560,7 @@
                 <a:spcPts val="300"/>
               </a:spcBef>
             </a:pPr>
-            <a:endParaRPr sz="1500" b="0" i="0">
+            <a:endParaRPr sz="1500" b="0" i="0" dirty="0">
               <a:solidFill>
                 <a:srgbClr val="1A1A1A"/>
               </a:solidFill>
@@ -8874,7 +8573,7 @@
               </a:spcBef>
             </a:pPr>
             <a:r>
-              <a:rPr sz="1600" b="1" i="0">
+              <a:rPr sz="1600" b="1" i="0" dirty="0">
                 <a:solidFill>
                   <a:srgbClr val="761D3E"/>
                 </a:solidFill>
@@ -8889,12 +8588,28 @@
               </a:spcBef>
             </a:pPr>
             <a:r>
-              <a:rPr sz="1500" b="0" i="0">
+              <a:rPr sz="1500" b="0" i="0" dirty="0">
                 <a:solidFill>
                   <a:srgbClr val="1A1A1A"/>
                 </a:solidFill>
               </a:rPr>
-              <a:t>11 modules built in time-boxed sprints in dependency order (e.g. Payment after Booking)</a:t>
+              <a:t>1</a:t>
+            </a:r>
+            <a:r>
+              <a:rPr lang="en-MY" sz="1500" b="0" i="0" dirty="0">
+                <a:solidFill>
+                  <a:srgbClr val="1A1A1A"/>
+                </a:solidFill>
+              </a:rPr>
+              <a:t>2</a:t>
+            </a:r>
+            <a:r>
+              <a:rPr sz="1500" b="0" i="0" dirty="0">
+                <a:solidFill>
+                  <a:srgbClr val="1A1A1A"/>
+                </a:solidFill>
+              </a:rPr>
+              <a:t> modules built in time-boxed sprints in dependency order (e.g. Payment after Booking)</a:t>
             </a:r>
           </a:p>
           <a:p>
@@ -8904,7 +8619,7 @@
               </a:spcBef>
             </a:pPr>
             <a:r>
-              <a:rPr sz="1500" b="0" i="0">
+              <a:rPr sz="1500" b="0" i="0" dirty="0">
                 <a:solidFill>
                   <a:srgbClr val="1A1A1A"/>
                 </a:solidFill>
@@ -8919,7 +8634,7 @@
               </a:spcBef>
             </a:pPr>
             <a:r>
-              <a:rPr sz="1500" b="0" i="0">
+              <a:rPr sz="1500" b="0" i="0" dirty="0">
                 <a:solidFill>
                   <a:srgbClr val="1A1A1A"/>
                 </a:solidFill>
@@ -8933,7 +8648,7 @@
                 <a:spcPts val="300"/>
               </a:spcBef>
             </a:pPr>
-            <a:endParaRPr sz="1500" b="0" i="0">
+            <a:endParaRPr sz="1500" b="0" i="0" dirty="0">
               <a:solidFill>
                 <a:srgbClr val="1A1A1A"/>
               </a:solidFill>
@@ -8946,7 +8661,7 @@
               </a:spcBef>
             </a:pPr>
             <a:r>
-              <a:rPr sz="1600" b="1" i="0">
+              <a:rPr sz="1600" b="1" i="0" dirty="0">
                 <a:solidFill>
                   <a:srgbClr val="761D3E"/>
                 </a:solidFill>
@@ -8961,7 +8676,7 @@
               </a:spcBef>
             </a:pPr>
             <a:r>
-              <a:rPr sz="1500" b="0" i="0">
+              <a:rPr sz="1500" b="0" i="0" dirty="0">
                 <a:solidFill>
                   <a:srgbClr val="1A1A1A"/>
                 </a:solidFill>
@@ -8975,7 +8690,7 @@
                 <a:spcPts val="300"/>
               </a:spcBef>
             </a:pPr>
-            <a:endParaRPr sz="1500" b="0" i="0">
+            <a:endParaRPr sz="1500" b="0" i="0" dirty="0">
               <a:solidFill>
                 <a:srgbClr val="1A1A1A"/>
               </a:solidFill>
@@ -8988,12 +8703,28 @@
               </a:spcBef>
             </a:pPr>
             <a:r>
-              <a:rPr sz="1400" b="1" i="0">
+              <a:rPr sz="1400" b="1" i="0" dirty="0">
                 <a:solidFill>
                   <a:srgbClr val="555555"/>
                 </a:solidFill>
               </a:rPr>
-              <a:t>Why hybrid? Waterfall gives the formal PSM documentation. Agile makes 11 modules trackable.</a:t>
+              <a:t>Why hybrid? Waterfall gives the formal PSM documentation. Agile makes 1</a:t>
+            </a:r>
+            <a:r>
+              <a:rPr lang="en-MY" sz="1400" b="1" i="0" dirty="0">
+                <a:solidFill>
+                  <a:srgbClr val="555555"/>
+                </a:solidFill>
+              </a:rPr>
+              <a:t>2</a:t>
+            </a:r>
+            <a:r>
+              <a:rPr sz="1400" b="1" i="0" dirty="0">
+                <a:solidFill>
+                  <a:srgbClr val="555555"/>
+                </a:solidFill>
+              </a:rPr>
+              <a:t> modules trackable.</a:t>
             </a:r>
           </a:p>
         </p:txBody>
@@ -9529,7 +9260,7 @@
           <a:bodyPr wrap="square"/>
           <a:lstStyle/>
           <a:p>
-            <a:pPr marL="0" indent="0" algn="ctr" eaLnBrk="1" hangingPunct="1">
+            <a:pPr marL="0" indent="0" eaLnBrk="1" hangingPunct="1">
               <a:spcBef>
                 <a:spcPts val="300"/>
               </a:spcBef>
@@ -9576,22 +9307,24 @@
             </a:r>
           </a:p>
           <a:p>
-            <a:pPr>
+            <a:pPr marL="0" indent="0">
               <a:spcBef>
                 <a:spcPts val="300"/>
               </a:spcBef>
-            </a:pPr>
-            <a:endParaRPr sz="1500" b="0" i="0" dirty="0">
+              <a:buNone/>
+            </a:pPr>
+            <a:endParaRPr lang="en-MY" sz="1500" dirty="0">
               <a:solidFill>
                 <a:srgbClr val="1A1A1A"/>
               </a:solidFill>
             </a:endParaRPr>
           </a:p>
           <a:p>
-            <a:pPr>
+            <a:pPr marL="0" indent="0">
               <a:spcBef>
                 <a:spcPts val="300"/>
               </a:spcBef>
+              <a:buNone/>
             </a:pPr>
             <a:r>
               <a:rPr sz="1600" b="1" i="0" dirty="0">
@@ -9680,488 +9413,6 @@
           </a:p>
         </p:txBody>
       </p:sp>
-      <p:graphicFrame>
-        <p:nvGraphicFramePr>
-          <p:cNvPr id="6" name="Table 5">
-            <a:extLst>
-              <a:ext uri="{FF2B5EF4-FFF2-40B4-BE49-F238E27FC236}">
-                <a16:creationId xmlns:a16="http://schemas.microsoft.com/office/drawing/2014/main" id="{1C01C51D-29C3-AD42-A565-36D87BD4F2F9}"/>
-              </a:ext>
-            </a:extLst>
-          </p:cNvPr>
-          <p:cNvGraphicFramePr>
-            <a:graphicFrameLocks noGrp="1"/>
-          </p:cNvGraphicFramePr>
-          <p:nvPr>
-            <p:extLst>
-              <p:ext uri="{D42A27DB-BD31-4B8C-83A1-F6EECF244321}">
-                <p14:modId xmlns:p14="http://schemas.microsoft.com/office/powerpoint/2010/main" val="2306416306"/>
-              </p:ext>
-            </p:extLst>
-          </p:nvPr>
-        </p:nvGraphicFramePr>
-        <p:xfrm>
-          <a:off x="1470025" y="2662238"/>
-          <a:ext cx="6873875" cy="1484312"/>
-        </p:xfrm>
-        <a:graphic>
-          <a:graphicData uri="http://schemas.openxmlformats.org/drawingml/2006/table">
-            <a:tbl>
-              <a:tblPr firstRow="1" bandRow="1">
-                <a:tableStyleId>{5C22544A-7EE6-4342-B048-85BDC9FD1C3A}</a:tableStyleId>
-              </a:tblPr>
-              <a:tblGrid>
-                <a:gridCol w="2302178">
-                  <a:extLst>
-                    <a:ext uri="{9D8B030D-6E8A-4147-A177-3AD203B41FA5}">
-                      <a16:colId xmlns:a16="http://schemas.microsoft.com/office/drawing/2014/main" val="2143797888"/>
-                    </a:ext>
-                  </a:extLst>
-                </a:gridCol>
-                <a:gridCol w="4571697">
-                  <a:extLst>
-                    <a:ext uri="{9D8B030D-6E8A-4147-A177-3AD203B41FA5}">
-                      <a16:colId xmlns:a16="http://schemas.microsoft.com/office/drawing/2014/main" val="1006590330"/>
-                    </a:ext>
-                  </a:extLst>
-                </a:gridCol>
-              </a:tblGrid>
-              <a:tr h="371078">
-                <a:tc>
-                  <a:txBody>
-                    <a:bodyPr/>
-                    <a:lstStyle/>
-                    <a:p>
-                      <a:pPr algn="ctr"/>
-                      <a:r>
-                        <a:rPr lang="en-US" sz="1800" b="1" dirty="0">
-                          <a:solidFill>
-                            <a:schemeClr val="tx1"/>
-                          </a:solidFill>
-                          <a:latin typeface="Microsoft Sans Serif" panose="020B0604020202020204" pitchFamily="34" charset="0"/>
-                          <a:cs typeface="Microsoft Sans Serif" panose="020B0604020202020204" pitchFamily="34" charset="0"/>
-                        </a:rPr>
-                        <a:t>Item</a:t>
-                      </a:r>
-                    </a:p>
-                  </a:txBody>
-                  <a:tcPr marL="91434" marR="91434" marT="45749" marB="45749">
-                    <a:lnL w="12700" cap="flat" cmpd="sng" algn="ctr">
-                      <a:solidFill>
-                        <a:schemeClr val="tx1"/>
-                      </a:solidFill>
-                      <a:prstDash val="solid"/>
-                      <a:round/>
-                      <a:headEnd type="none" w="med" len="med"/>
-                      <a:tailEnd type="none" w="med" len="med"/>
-                    </a:lnL>
-                    <a:lnR w="12700" cap="flat" cmpd="sng" algn="ctr">
-                      <a:solidFill>
-                        <a:schemeClr val="tx1"/>
-                      </a:solidFill>
-                      <a:prstDash val="solid"/>
-                      <a:round/>
-                      <a:headEnd type="none" w="med" len="med"/>
-                      <a:tailEnd type="none" w="med" len="med"/>
-                    </a:lnR>
-                    <a:lnT w="12700" cap="flat" cmpd="sng" algn="ctr">
-                      <a:solidFill>
-                        <a:schemeClr val="tx1"/>
-                      </a:solidFill>
-                      <a:prstDash val="solid"/>
-                      <a:round/>
-                      <a:headEnd type="none" w="med" len="med"/>
-                      <a:tailEnd type="none" w="med" len="med"/>
-                    </a:lnT>
-                    <a:lnB w="12700" cap="flat" cmpd="sng" algn="ctr">
-                      <a:solidFill>
-                        <a:schemeClr val="tx1"/>
-                      </a:solidFill>
-                      <a:prstDash val="solid"/>
-                      <a:round/>
-                      <a:headEnd type="none" w="med" len="med"/>
-                      <a:tailEnd type="none" w="med" len="med"/>
-                    </a:lnB>
-                    <a:noFill/>
-                  </a:tcPr>
-                </a:tc>
-                <a:tc>
-                  <a:txBody>
-                    <a:bodyPr/>
-                    <a:lstStyle/>
-                    <a:p>
-                      <a:pPr algn="ctr"/>
-                      <a:r>
-                        <a:rPr lang="en-US" sz="1800" b="1" dirty="0">
-                          <a:solidFill>
-                            <a:schemeClr val="tx1"/>
-                          </a:solidFill>
-                          <a:latin typeface="Microsoft Sans Serif" panose="020B0604020202020204" pitchFamily="34" charset="0"/>
-                          <a:cs typeface="Microsoft Sans Serif" panose="020B0604020202020204" pitchFamily="34" charset="0"/>
-                        </a:rPr>
-                        <a:t>Description</a:t>
-                      </a:r>
-                    </a:p>
-                  </a:txBody>
-                  <a:tcPr marL="91434" marR="91434" marT="45749" marB="45749">
-                    <a:lnL w="12700" cap="flat" cmpd="sng" algn="ctr">
-                      <a:solidFill>
-                        <a:schemeClr val="tx1"/>
-                      </a:solidFill>
-                      <a:prstDash val="solid"/>
-                      <a:round/>
-                      <a:headEnd type="none" w="med" len="med"/>
-                      <a:tailEnd type="none" w="med" len="med"/>
-                    </a:lnL>
-                    <a:lnR w="12700" cap="flat" cmpd="sng" algn="ctr">
-                      <a:solidFill>
-                        <a:schemeClr val="tx1"/>
-                      </a:solidFill>
-                      <a:prstDash val="solid"/>
-                      <a:round/>
-                      <a:headEnd type="none" w="med" len="med"/>
-                      <a:tailEnd type="none" w="med" len="med"/>
-                    </a:lnR>
-                    <a:lnT w="12700" cap="flat" cmpd="sng" algn="ctr">
-                      <a:solidFill>
-                        <a:schemeClr val="tx1"/>
-                      </a:solidFill>
-                      <a:prstDash val="solid"/>
-                      <a:round/>
-                      <a:headEnd type="none" w="med" len="med"/>
-                      <a:tailEnd type="none" w="med" len="med"/>
-                    </a:lnT>
-                    <a:lnB w="12700" cap="flat" cmpd="sng" algn="ctr">
-                      <a:solidFill>
-                        <a:schemeClr val="tx1"/>
-                      </a:solidFill>
-                      <a:prstDash val="solid"/>
-                      <a:round/>
-                      <a:headEnd type="none" w="med" len="med"/>
-                      <a:tailEnd type="none" w="med" len="med"/>
-                    </a:lnB>
-                    <a:noFill/>
-                  </a:tcPr>
-                </a:tc>
-                <a:extLst>
-                  <a:ext uri="{0D108BD9-81ED-4DB2-BD59-A6C34878D82A}">
-                    <a16:rowId xmlns:a16="http://schemas.microsoft.com/office/drawing/2014/main" val="3127784443"/>
-                  </a:ext>
-                </a:extLst>
-              </a:tr>
-              <a:tr h="371078">
-                <a:tc>
-                  <a:txBody>
-                    <a:bodyPr/>
-                    <a:lstStyle/>
-                    <a:p>
-                      <a:endParaRPr lang="en-US" sz="1800" dirty="0"/>
-                    </a:p>
-                  </a:txBody>
-                  <a:tcPr marL="91434" marR="91434" marT="45749" marB="45749">
-                    <a:lnL w="12700" cap="flat" cmpd="sng" algn="ctr">
-                      <a:solidFill>
-                        <a:schemeClr val="tx1"/>
-                      </a:solidFill>
-                      <a:prstDash val="solid"/>
-                      <a:round/>
-                      <a:headEnd type="none" w="med" len="med"/>
-                      <a:tailEnd type="none" w="med" len="med"/>
-                    </a:lnL>
-                    <a:lnR w="12700" cap="flat" cmpd="sng" algn="ctr">
-                      <a:solidFill>
-                        <a:schemeClr val="tx1"/>
-                      </a:solidFill>
-                      <a:prstDash val="solid"/>
-                      <a:round/>
-                      <a:headEnd type="none" w="med" len="med"/>
-                      <a:tailEnd type="none" w="med" len="med"/>
-                    </a:lnR>
-                    <a:lnT w="12700" cap="flat" cmpd="sng" algn="ctr">
-                      <a:solidFill>
-                        <a:schemeClr val="tx1"/>
-                      </a:solidFill>
-                      <a:prstDash val="solid"/>
-                      <a:round/>
-                      <a:headEnd type="none" w="med" len="med"/>
-                      <a:tailEnd type="none" w="med" len="med"/>
-                    </a:lnT>
-                    <a:lnB w="12700" cap="flat" cmpd="sng" algn="ctr">
-                      <a:solidFill>
-                        <a:schemeClr val="tx1"/>
-                      </a:solidFill>
-                      <a:prstDash val="solid"/>
-                      <a:round/>
-                      <a:headEnd type="none" w="med" len="med"/>
-                      <a:tailEnd type="none" w="med" len="med"/>
-                    </a:lnB>
-                    <a:noFill/>
-                  </a:tcPr>
-                </a:tc>
-                <a:tc>
-                  <a:txBody>
-                    <a:bodyPr/>
-                    <a:lstStyle/>
-                    <a:p>
-                      <a:endParaRPr lang="en-US" sz="1800" dirty="0"/>
-                    </a:p>
-                  </a:txBody>
-                  <a:tcPr marL="91434" marR="91434" marT="45749" marB="45749">
-                    <a:lnL w="12700" cap="flat" cmpd="sng" algn="ctr">
-                      <a:solidFill>
-                        <a:schemeClr val="tx1"/>
-                      </a:solidFill>
-                      <a:prstDash val="solid"/>
-                      <a:round/>
-                      <a:headEnd type="none" w="med" len="med"/>
-                      <a:tailEnd type="none" w="med" len="med"/>
-                    </a:lnL>
-                    <a:lnR w="12700" cap="flat" cmpd="sng" algn="ctr">
-                      <a:solidFill>
-                        <a:schemeClr val="tx1"/>
-                      </a:solidFill>
-                      <a:prstDash val="solid"/>
-                      <a:round/>
-                      <a:headEnd type="none" w="med" len="med"/>
-                      <a:tailEnd type="none" w="med" len="med"/>
-                    </a:lnR>
-                    <a:lnT w="12700" cap="flat" cmpd="sng" algn="ctr">
-                      <a:solidFill>
-                        <a:schemeClr val="tx1"/>
-                      </a:solidFill>
-                      <a:prstDash val="solid"/>
-                      <a:round/>
-                      <a:headEnd type="none" w="med" len="med"/>
-                      <a:tailEnd type="none" w="med" len="med"/>
-                    </a:lnT>
-                    <a:lnB w="12700" cap="flat" cmpd="sng" algn="ctr">
-                      <a:solidFill>
-                        <a:schemeClr val="tx1"/>
-                      </a:solidFill>
-                      <a:prstDash val="solid"/>
-                      <a:round/>
-                      <a:headEnd type="none" w="med" len="med"/>
-                      <a:tailEnd type="none" w="med" len="med"/>
-                    </a:lnB>
-                    <a:noFill/>
-                  </a:tcPr>
-                </a:tc>
-                <a:extLst>
-                  <a:ext uri="{0D108BD9-81ED-4DB2-BD59-A6C34878D82A}">
-                    <a16:rowId xmlns:a16="http://schemas.microsoft.com/office/drawing/2014/main" val="3503737699"/>
-                  </a:ext>
-                </a:extLst>
-              </a:tr>
-              <a:tr h="371078">
-                <a:tc>
-                  <a:txBody>
-                    <a:bodyPr/>
-                    <a:lstStyle/>
-                    <a:p>
-                      <a:endParaRPr lang="en-US" sz="1800" dirty="0"/>
-                    </a:p>
-                  </a:txBody>
-                  <a:tcPr marL="91434" marR="91434" marT="45749" marB="45749">
-                    <a:lnL w="12700" cap="flat" cmpd="sng" algn="ctr">
-                      <a:solidFill>
-                        <a:schemeClr val="tx1"/>
-                      </a:solidFill>
-                      <a:prstDash val="solid"/>
-                      <a:round/>
-                      <a:headEnd type="none" w="med" len="med"/>
-                      <a:tailEnd type="none" w="med" len="med"/>
-                    </a:lnL>
-                    <a:lnR w="12700" cap="flat" cmpd="sng" algn="ctr">
-                      <a:solidFill>
-                        <a:schemeClr val="tx1"/>
-                      </a:solidFill>
-                      <a:prstDash val="solid"/>
-                      <a:round/>
-                      <a:headEnd type="none" w="med" len="med"/>
-                      <a:tailEnd type="none" w="med" len="med"/>
-                    </a:lnR>
-                    <a:lnT w="12700" cap="flat" cmpd="sng" algn="ctr">
-                      <a:solidFill>
-                        <a:schemeClr val="tx1"/>
-                      </a:solidFill>
-                      <a:prstDash val="solid"/>
-                      <a:round/>
-                      <a:headEnd type="none" w="med" len="med"/>
-                      <a:tailEnd type="none" w="med" len="med"/>
-                    </a:lnT>
-                    <a:lnB w="12700" cap="flat" cmpd="sng" algn="ctr">
-                      <a:solidFill>
-                        <a:schemeClr val="tx1"/>
-                      </a:solidFill>
-                      <a:prstDash val="solid"/>
-                      <a:round/>
-                      <a:headEnd type="none" w="med" len="med"/>
-                      <a:tailEnd type="none" w="med" len="med"/>
-                    </a:lnB>
-                    <a:noFill/>
-                  </a:tcPr>
-                </a:tc>
-                <a:tc>
-                  <a:txBody>
-                    <a:bodyPr/>
-                    <a:lstStyle/>
-                    <a:p>
-                      <a:endParaRPr lang="en-US" sz="1800" dirty="0"/>
-                    </a:p>
-                  </a:txBody>
-                  <a:tcPr marL="91434" marR="91434" marT="45749" marB="45749">
-                    <a:lnL w="12700" cap="flat" cmpd="sng" algn="ctr">
-                      <a:solidFill>
-                        <a:schemeClr val="tx1"/>
-                      </a:solidFill>
-                      <a:prstDash val="solid"/>
-                      <a:round/>
-                      <a:headEnd type="none" w="med" len="med"/>
-                      <a:tailEnd type="none" w="med" len="med"/>
-                    </a:lnL>
-                    <a:lnR w="12700" cap="flat" cmpd="sng" algn="ctr">
-                      <a:solidFill>
-                        <a:schemeClr val="tx1"/>
-                      </a:solidFill>
-                      <a:prstDash val="solid"/>
-                      <a:round/>
-                      <a:headEnd type="none" w="med" len="med"/>
-                      <a:tailEnd type="none" w="med" len="med"/>
-                    </a:lnR>
-                    <a:lnT w="12700" cap="flat" cmpd="sng" algn="ctr">
-                      <a:solidFill>
-                        <a:schemeClr val="tx1"/>
-                      </a:solidFill>
-                      <a:prstDash val="solid"/>
-                      <a:round/>
-                      <a:headEnd type="none" w="med" len="med"/>
-                      <a:tailEnd type="none" w="med" len="med"/>
-                    </a:lnT>
-                    <a:lnB w="12700" cap="flat" cmpd="sng" algn="ctr">
-                      <a:solidFill>
-                        <a:schemeClr val="tx1"/>
-                      </a:solidFill>
-                      <a:prstDash val="solid"/>
-                      <a:round/>
-                      <a:headEnd type="none" w="med" len="med"/>
-                      <a:tailEnd type="none" w="med" len="med"/>
-                    </a:lnB>
-                    <a:noFill/>
-                  </a:tcPr>
-                </a:tc>
-                <a:extLst>
-                  <a:ext uri="{0D108BD9-81ED-4DB2-BD59-A6C34878D82A}">
-                    <a16:rowId xmlns:a16="http://schemas.microsoft.com/office/drawing/2014/main" val="3255115357"/>
-                  </a:ext>
-                </a:extLst>
-              </a:tr>
-              <a:tr h="371078">
-                <a:tc>
-                  <a:txBody>
-                    <a:bodyPr/>
-                    <a:lstStyle/>
-                    <a:p>
-                      <a:endParaRPr lang="en-US" sz="1800"/>
-                    </a:p>
-                  </a:txBody>
-                  <a:tcPr marL="91434" marR="91434" marT="45749" marB="45749">
-                    <a:lnL w="12700" cap="flat" cmpd="sng" algn="ctr">
-                      <a:solidFill>
-                        <a:schemeClr val="tx1"/>
-                      </a:solidFill>
-                      <a:prstDash val="solid"/>
-                      <a:round/>
-                      <a:headEnd type="none" w="med" len="med"/>
-                      <a:tailEnd type="none" w="med" len="med"/>
-                    </a:lnL>
-                    <a:lnR w="12700" cap="flat" cmpd="sng" algn="ctr">
-                      <a:solidFill>
-                        <a:schemeClr val="tx1"/>
-                      </a:solidFill>
-                      <a:prstDash val="solid"/>
-                      <a:round/>
-                      <a:headEnd type="none" w="med" len="med"/>
-                      <a:tailEnd type="none" w="med" len="med"/>
-                    </a:lnR>
-                    <a:lnT w="12700" cap="flat" cmpd="sng" algn="ctr">
-                      <a:solidFill>
-                        <a:schemeClr val="tx1"/>
-                      </a:solidFill>
-                      <a:prstDash val="solid"/>
-                      <a:round/>
-                      <a:headEnd type="none" w="med" len="med"/>
-                      <a:tailEnd type="none" w="med" len="med"/>
-                    </a:lnT>
-                    <a:lnB w="12700" cap="flat" cmpd="sng" algn="ctr">
-                      <a:solidFill>
-                        <a:schemeClr val="tx1"/>
-                      </a:solidFill>
-                      <a:prstDash val="solid"/>
-                      <a:round/>
-                      <a:headEnd type="none" w="med" len="med"/>
-                      <a:tailEnd type="none" w="med" len="med"/>
-                    </a:lnB>
-                    <a:noFill/>
-                  </a:tcPr>
-                </a:tc>
-                <a:tc>
-                  <a:txBody>
-                    <a:bodyPr/>
-                    <a:lstStyle/>
-                    <a:p>
-                      <a:endParaRPr lang="en-US" sz="1800" dirty="0"/>
-                    </a:p>
-                  </a:txBody>
-                  <a:tcPr marL="91434" marR="91434" marT="45749" marB="45749">
-                    <a:lnL w="12700" cap="flat" cmpd="sng" algn="ctr">
-                      <a:solidFill>
-                        <a:schemeClr val="tx1"/>
-                      </a:solidFill>
-                      <a:prstDash val="solid"/>
-                      <a:round/>
-                      <a:headEnd type="none" w="med" len="med"/>
-                      <a:tailEnd type="none" w="med" len="med"/>
-                    </a:lnL>
-                    <a:lnR w="12700" cap="flat" cmpd="sng" algn="ctr">
-                      <a:solidFill>
-                        <a:schemeClr val="tx1"/>
-                      </a:solidFill>
-                      <a:prstDash val="solid"/>
-                      <a:round/>
-                      <a:headEnd type="none" w="med" len="med"/>
-                      <a:tailEnd type="none" w="med" len="med"/>
-                    </a:lnR>
-                    <a:lnT w="12700" cap="flat" cmpd="sng" algn="ctr">
-                      <a:solidFill>
-                        <a:schemeClr val="tx1"/>
-                      </a:solidFill>
-                      <a:prstDash val="solid"/>
-                      <a:round/>
-                      <a:headEnd type="none" w="med" len="med"/>
-                      <a:tailEnd type="none" w="med" len="med"/>
-                    </a:lnT>
-                    <a:lnB w="12700" cap="flat" cmpd="sng" algn="ctr">
-                      <a:solidFill>
-                        <a:schemeClr val="tx1"/>
-                      </a:solidFill>
-                      <a:prstDash val="solid"/>
-                      <a:round/>
-                      <a:headEnd type="none" w="med" len="med"/>
-                      <a:tailEnd type="none" w="med" len="med"/>
-                    </a:lnB>
-                    <a:noFill/>
-                  </a:tcPr>
-                </a:tc>
-                <a:extLst>
-                  <a:ext uri="{0D108BD9-81ED-4DB2-BD59-A6C34878D82A}">
-                    <a16:rowId xmlns:a16="http://schemas.microsoft.com/office/drawing/2014/main" val="2318133102"/>
-                  </a:ext>
-                </a:extLst>
-              </a:tr>
-            </a:tbl>
-          </a:graphicData>
-        </a:graphic>
-      </p:graphicFrame>
       <p:sp>
         <p:nvSpPr>
           <p:cNvPr id="7" name="TextBox 6">
@@ -10606,7 +9857,7 @@
           <a:bodyPr wrap="square"/>
           <a:lstStyle/>
           <a:p>
-            <a:pPr marL="0" indent="0" algn="ctr" eaLnBrk="1" hangingPunct="1">
+            <a:pPr marL="0" indent="0" eaLnBrk="1" hangingPunct="1">
               <a:spcBef>
                 <a:spcPts val="300"/>
               </a:spcBef>
@@ -10749,10 +10000,11 @@
             </a:endParaRPr>
           </a:p>
           <a:p>
-            <a:pPr>
+            <a:pPr marL="0" indent="0">
               <a:spcBef>
                 <a:spcPts val="300"/>
               </a:spcBef>
+              <a:buNone/>
             </a:pPr>
             <a:r>
               <a:rPr sz="1600" b="1" i="0" dirty="0">
@@ -10775,7 +10027,39 @@
                   <a:srgbClr val="1A1A1A"/>
                 </a:solidFill>
               </a:rPr>
-              <a:t>Ubuntu Server 22.04 LTS  |  Nginx  |  PHP-FPM 8.2  |  Composer</a:t>
+              <a:t>Ubuntu Server 22.04 LTS  |  </a:t>
+            </a:r>
+            <a:r>
+              <a:rPr lang="en-MY" sz="1500" b="0" i="0" dirty="0">
+                <a:solidFill>
+                  <a:srgbClr val="1A1A1A"/>
+                </a:solidFill>
+              </a:rPr>
+              <a:t>Apache</a:t>
+            </a:r>
+            <a:r>
+              <a:rPr sz="1500" b="0" i="0" dirty="0">
+                <a:solidFill>
+                  <a:srgbClr val="1A1A1A"/>
+                </a:solidFill>
+              </a:rPr>
+              <a:t>  |  PHP-FPM 8.</a:t>
+            </a:r>
+            <a:r>
+              <a:rPr lang="en-MY" sz="1500" b="0" i="0" dirty="0">
+                <a:solidFill>
+                  <a:srgbClr val="1A1A1A"/>
+                </a:solidFill>
+              </a:rPr>
+              <a:t>3</a:t>
+            </a:r>
+            <a:r>
+              <a:rPr sz="1500" b="0" i="0" dirty="0">
+                <a:solidFill>
+                  <a:srgbClr val="1A1A1A"/>
+                </a:solidFill>
+              </a:rPr>
+              <a:t>  |  Composer</a:t>
             </a:r>
           </a:p>
           <a:p>
@@ -10842,482 +10126,6 @@
           </a:p>
         </p:txBody>
       </p:sp>
-      <p:graphicFrame>
-        <p:nvGraphicFramePr>
-          <p:cNvPr id="6" name="Table 5">
-            <a:extLst>
-              <a:ext uri="{FF2B5EF4-FFF2-40B4-BE49-F238E27FC236}">
-                <a16:creationId xmlns:a16="http://schemas.microsoft.com/office/drawing/2014/main" id="{1C01C51D-29C3-AD42-A565-36D87BD4F2F9}"/>
-              </a:ext>
-            </a:extLst>
-          </p:cNvPr>
-          <p:cNvGraphicFramePr>
-            <a:graphicFrameLocks noGrp="1"/>
-          </p:cNvGraphicFramePr>
-          <p:nvPr/>
-        </p:nvGraphicFramePr>
-        <p:xfrm>
-          <a:off x="1470025" y="2662238"/>
-          <a:ext cx="6873875" cy="1484312"/>
-        </p:xfrm>
-        <a:graphic>
-          <a:graphicData uri="http://schemas.openxmlformats.org/drawingml/2006/table">
-            <a:tbl>
-              <a:tblPr firstRow="1" bandRow="1">
-                <a:tableStyleId>{5C22544A-7EE6-4342-B048-85BDC9FD1C3A}</a:tableStyleId>
-              </a:tblPr>
-              <a:tblGrid>
-                <a:gridCol w="2302178">
-                  <a:extLst>
-                    <a:ext uri="{9D8B030D-6E8A-4147-A177-3AD203B41FA5}">
-                      <a16:colId xmlns:a16="http://schemas.microsoft.com/office/drawing/2014/main" val="2143797888"/>
-                    </a:ext>
-                  </a:extLst>
-                </a:gridCol>
-                <a:gridCol w="4571697">
-                  <a:extLst>
-                    <a:ext uri="{9D8B030D-6E8A-4147-A177-3AD203B41FA5}">
-                      <a16:colId xmlns:a16="http://schemas.microsoft.com/office/drawing/2014/main" val="1006590330"/>
-                    </a:ext>
-                  </a:extLst>
-                </a:gridCol>
-              </a:tblGrid>
-              <a:tr h="371078">
-                <a:tc>
-                  <a:txBody>
-                    <a:bodyPr/>
-                    <a:lstStyle/>
-                    <a:p>
-                      <a:pPr algn="ctr"/>
-                      <a:r>
-                        <a:rPr lang="en-US" sz="1800" b="1" dirty="0">
-                          <a:solidFill>
-                            <a:schemeClr val="tx1"/>
-                          </a:solidFill>
-                          <a:latin typeface="Microsoft Sans Serif" panose="020B0604020202020204" pitchFamily="34" charset="0"/>
-                          <a:cs typeface="Microsoft Sans Serif" panose="020B0604020202020204" pitchFamily="34" charset="0"/>
-                        </a:rPr>
-                        <a:t>Item</a:t>
-                      </a:r>
-                    </a:p>
-                  </a:txBody>
-                  <a:tcPr marL="91434" marR="91434" marT="45749" marB="45749">
-                    <a:lnL w="12700" cap="flat" cmpd="sng" algn="ctr">
-                      <a:solidFill>
-                        <a:schemeClr val="tx1"/>
-                      </a:solidFill>
-                      <a:prstDash val="solid"/>
-                      <a:round/>
-                      <a:headEnd type="none" w="med" len="med"/>
-                      <a:tailEnd type="none" w="med" len="med"/>
-                    </a:lnL>
-                    <a:lnR w="12700" cap="flat" cmpd="sng" algn="ctr">
-                      <a:solidFill>
-                        <a:schemeClr val="tx1"/>
-                      </a:solidFill>
-                      <a:prstDash val="solid"/>
-                      <a:round/>
-                      <a:headEnd type="none" w="med" len="med"/>
-                      <a:tailEnd type="none" w="med" len="med"/>
-                    </a:lnR>
-                    <a:lnT w="12700" cap="flat" cmpd="sng" algn="ctr">
-                      <a:solidFill>
-                        <a:schemeClr val="tx1"/>
-                      </a:solidFill>
-                      <a:prstDash val="solid"/>
-                      <a:round/>
-                      <a:headEnd type="none" w="med" len="med"/>
-                      <a:tailEnd type="none" w="med" len="med"/>
-                    </a:lnT>
-                    <a:lnB w="12700" cap="flat" cmpd="sng" algn="ctr">
-                      <a:solidFill>
-                        <a:schemeClr val="tx1"/>
-                      </a:solidFill>
-                      <a:prstDash val="solid"/>
-                      <a:round/>
-                      <a:headEnd type="none" w="med" len="med"/>
-                      <a:tailEnd type="none" w="med" len="med"/>
-                    </a:lnB>
-                    <a:noFill/>
-                  </a:tcPr>
-                </a:tc>
-                <a:tc>
-                  <a:txBody>
-                    <a:bodyPr/>
-                    <a:lstStyle/>
-                    <a:p>
-                      <a:pPr algn="ctr"/>
-                      <a:r>
-                        <a:rPr lang="en-US" sz="1800" b="1" dirty="0">
-                          <a:solidFill>
-                            <a:schemeClr val="tx1"/>
-                          </a:solidFill>
-                          <a:latin typeface="Microsoft Sans Serif" panose="020B0604020202020204" pitchFamily="34" charset="0"/>
-                          <a:cs typeface="Microsoft Sans Serif" panose="020B0604020202020204" pitchFamily="34" charset="0"/>
-                        </a:rPr>
-                        <a:t>Description</a:t>
-                      </a:r>
-                    </a:p>
-                  </a:txBody>
-                  <a:tcPr marL="91434" marR="91434" marT="45749" marB="45749">
-                    <a:lnL w="12700" cap="flat" cmpd="sng" algn="ctr">
-                      <a:solidFill>
-                        <a:schemeClr val="tx1"/>
-                      </a:solidFill>
-                      <a:prstDash val="solid"/>
-                      <a:round/>
-                      <a:headEnd type="none" w="med" len="med"/>
-                      <a:tailEnd type="none" w="med" len="med"/>
-                    </a:lnL>
-                    <a:lnR w="12700" cap="flat" cmpd="sng" algn="ctr">
-                      <a:solidFill>
-                        <a:schemeClr val="tx1"/>
-                      </a:solidFill>
-                      <a:prstDash val="solid"/>
-                      <a:round/>
-                      <a:headEnd type="none" w="med" len="med"/>
-                      <a:tailEnd type="none" w="med" len="med"/>
-                    </a:lnR>
-                    <a:lnT w="12700" cap="flat" cmpd="sng" algn="ctr">
-                      <a:solidFill>
-                        <a:schemeClr val="tx1"/>
-                      </a:solidFill>
-                      <a:prstDash val="solid"/>
-                      <a:round/>
-                      <a:headEnd type="none" w="med" len="med"/>
-                      <a:tailEnd type="none" w="med" len="med"/>
-                    </a:lnT>
-                    <a:lnB w="12700" cap="flat" cmpd="sng" algn="ctr">
-                      <a:solidFill>
-                        <a:schemeClr val="tx1"/>
-                      </a:solidFill>
-                      <a:prstDash val="solid"/>
-                      <a:round/>
-                      <a:headEnd type="none" w="med" len="med"/>
-                      <a:tailEnd type="none" w="med" len="med"/>
-                    </a:lnB>
-                    <a:noFill/>
-                  </a:tcPr>
-                </a:tc>
-                <a:extLst>
-                  <a:ext uri="{0D108BD9-81ED-4DB2-BD59-A6C34878D82A}">
-                    <a16:rowId xmlns:a16="http://schemas.microsoft.com/office/drawing/2014/main" val="3127784443"/>
-                  </a:ext>
-                </a:extLst>
-              </a:tr>
-              <a:tr h="371078">
-                <a:tc>
-                  <a:txBody>
-                    <a:bodyPr/>
-                    <a:lstStyle/>
-                    <a:p>
-                      <a:endParaRPr lang="en-US" sz="1800" dirty="0"/>
-                    </a:p>
-                  </a:txBody>
-                  <a:tcPr marL="91434" marR="91434" marT="45749" marB="45749">
-                    <a:lnL w="12700" cap="flat" cmpd="sng" algn="ctr">
-                      <a:solidFill>
-                        <a:schemeClr val="tx1"/>
-                      </a:solidFill>
-                      <a:prstDash val="solid"/>
-                      <a:round/>
-                      <a:headEnd type="none" w="med" len="med"/>
-                      <a:tailEnd type="none" w="med" len="med"/>
-                    </a:lnL>
-                    <a:lnR w="12700" cap="flat" cmpd="sng" algn="ctr">
-                      <a:solidFill>
-                        <a:schemeClr val="tx1"/>
-                      </a:solidFill>
-                      <a:prstDash val="solid"/>
-                      <a:round/>
-                      <a:headEnd type="none" w="med" len="med"/>
-                      <a:tailEnd type="none" w="med" len="med"/>
-                    </a:lnR>
-                    <a:lnT w="12700" cap="flat" cmpd="sng" algn="ctr">
-                      <a:solidFill>
-                        <a:schemeClr val="tx1"/>
-                      </a:solidFill>
-                      <a:prstDash val="solid"/>
-                      <a:round/>
-                      <a:headEnd type="none" w="med" len="med"/>
-                      <a:tailEnd type="none" w="med" len="med"/>
-                    </a:lnT>
-                    <a:lnB w="12700" cap="flat" cmpd="sng" algn="ctr">
-                      <a:solidFill>
-                        <a:schemeClr val="tx1"/>
-                      </a:solidFill>
-                      <a:prstDash val="solid"/>
-                      <a:round/>
-                      <a:headEnd type="none" w="med" len="med"/>
-                      <a:tailEnd type="none" w="med" len="med"/>
-                    </a:lnB>
-                    <a:noFill/>
-                  </a:tcPr>
-                </a:tc>
-                <a:tc>
-                  <a:txBody>
-                    <a:bodyPr/>
-                    <a:lstStyle/>
-                    <a:p>
-                      <a:endParaRPr lang="en-US" sz="1800" dirty="0"/>
-                    </a:p>
-                  </a:txBody>
-                  <a:tcPr marL="91434" marR="91434" marT="45749" marB="45749">
-                    <a:lnL w="12700" cap="flat" cmpd="sng" algn="ctr">
-                      <a:solidFill>
-                        <a:schemeClr val="tx1"/>
-                      </a:solidFill>
-                      <a:prstDash val="solid"/>
-                      <a:round/>
-                      <a:headEnd type="none" w="med" len="med"/>
-                      <a:tailEnd type="none" w="med" len="med"/>
-                    </a:lnL>
-                    <a:lnR w="12700" cap="flat" cmpd="sng" algn="ctr">
-                      <a:solidFill>
-                        <a:schemeClr val="tx1"/>
-                      </a:solidFill>
-                      <a:prstDash val="solid"/>
-                      <a:round/>
-                      <a:headEnd type="none" w="med" len="med"/>
-                      <a:tailEnd type="none" w="med" len="med"/>
-                    </a:lnR>
-                    <a:lnT w="12700" cap="flat" cmpd="sng" algn="ctr">
-                      <a:solidFill>
-                        <a:schemeClr val="tx1"/>
-                      </a:solidFill>
-                      <a:prstDash val="solid"/>
-                      <a:round/>
-                      <a:headEnd type="none" w="med" len="med"/>
-                      <a:tailEnd type="none" w="med" len="med"/>
-                    </a:lnT>
-                    <a:lnB w="12700" cap="flat" cmpd="sng" algn="ctr">
-                      <a:solidFill>
-                        <a:schemeClr val="tx1"/>
-                      </a:solidFill>
-                      <a:prstDash val="solid"/>
-                      <a:round/>
-                      <a:headEnd type="none" w="med" len="med"/>
-                      <a:tailEnd type="none" w="med" len="med"/>
-                    </a:lnB>
-                    <a:noFill/>
-                  </a:tcPr>
-                </a:tc>
-                <a:extLst>
-                  <a:ext uri="{0D108BD9-81ED-4DB2-BD59-A6C34878D82A}">
-                    <a16:rowId xmlns:a16="http://schemas.microsoft.com/office/drawing/2014/main" val="3503737699"/>
-                  </a:ext>
-                </a:extLst>
-              </a:tr>
-              <a:tr h="371078">
-                <a:tc>
-                  <a:txBody>
-                    <a:bodyPr/>
-                    <a:lstStyle/>
-                    <a:p>
-                      <a:endParaRPr lang="en-US" sz="1800"/>
-                    </a:p>
-                  </a:txBody>
-                  <a:tcPr marL="91434" marR="91434" marT="45749" marB="45749">
-                    <a:lnL w="12700" cap="flat" cmpd="sng" algn="ctr">
-                      <a:solidFill>
-                        <a:schemeClr val="tx1"/>
-                      </a:solidFill>
-                      <a:prstDash val="solid"/>
-                      <a:round/>
-                      <a:headEnd type="none" w="med" len="med"/>
-                      <a:tailEnd type="none" w="med" len="med"/>
-                    </a:lnL>
-                    <a:lnR w="12700" cap="flat" cmpd="sng" algn="ctr">
-                      <a:solidFill>
-                        <a:schemeClr val="tx1"/>
-                      </a:solidFill>
-                      <a:prstDash val="solid"/>
-                      <a:round/>
-                      <a:headEnd type="none" w="med" len="med"/>
-                      <a:tailEnd type="none" w="med" len="med"/>
-                    </a:lnR>
-                    <a:lnT w="12700" cap="flat" cmpd="sng" algn="ctr">
-                      <a:solidFill>
-                        <a:schemeClr val="tx1"/>
-                      </a:solidFill>
-                      <a:prstDash val="solid"/>
-                      <a:round/>
-                      <a:headEnd type="none" w="med" len="med"/>
-                      <a:tailEnd type="none" w="med" len="med"/>
-                    </a:lnT>
-                    <a:lnB w="12700" cap="flat" cmpd="sng" algn="ctr">
-                      <a:solidFill>
-                        <a:schemeClr val="tx1"/>
-                      </a:solidFill>
-                      <a:prstDash val="solid"/>
-                      <a:round/>
-                      <a:headEnd type="none" w="med" len="med"/>
-                      <a:tailEnd type="none" w="med" len="med"/>
-                    </a:lnB>
-                    <a:noFill/>
-                  </a:tcPr>
-                </a:tc>
-                <a:tc>
-                  <a:txBody>
-                    <a:bodyPr/>
-                    <a:lstStyle/>
-                    <a:p>
-                      <a:endParaRPr lang="en-US" sz="1800" dirty="0"/>
-                    </a:p>
-                  </a:txBody>
-                  <a:tcPr marL="91434" marR="91434" marT="45749" marB="45749">
-                    <a:lnL w="12700" cap="flat" cmpd="sng" algn="ctr">
-                      <a:solidFill>
-                        <a:schemeClr val="tx1"/>
-                      </a:solidFill>
-                      <a:prstDash val="solid"/>
-                      <a:round/>
-                      <a:headEnd type="none" w="med" len="med"/>
-                      <a:tailEnd type="none" w="med" len="med"/>
-                    </a:lnL>
-                    <a:lnR w="12700" cap="flat" cmpd="sng" algn="ctr">
-                      <a:solidFill>
-                        <a:schemeClr val="tx1"/>
-                      </a:solidFill>
-                      <a:prstDash val="solid"/>
-                      <a:round/>
-                      <a:headEnd type="none" w="med" len="med"/>
-                      <a:tailEnd type="none" w="med" len="med"/>
-                    </a:lnR>
-                    <a:lnT w="12700" cap="flat" cmpd="sng" algn="ctr">
-                      <a:solidFill>
-                        <a:schemeClr val="tx1"/>
-                      </a:solidFill>
-                      <a:prstDash val="solid"/>
-                      <a:round/>
-                      <a:headEnd type="none" w="med" len="med"/>
-                      <a:tailEnd type="none" w="med" len="med"/>
-                    </a:lnT>
-                    <a:lnB w="12700" cap="flat" cmpd="sng" algn="ctr">
-                      <a:solidFill>
-                        <a:schemeClr val="tx1"/>
-                      </a:solidFill>
-                      <a:prstDash val="solid"/>
-                      <a:round/>
-                      <a:headEnd type="none" w="med" len="med"/>
-                      <a:tailEnd type="none" w="med" len="med"/>
-                    </a:lnB>
-                    <a:noFill/>
-                  </a:tcPr>
-                </a:tc>
-                <a:extLst>
-                  <a:ext uri="{0D108BD9-81ED-4DB2-BD59-A6C34878D82A}">
-                    <a16:rowId xmlns:a16="http://schemas.microsoft.com/office/drawing/2014/main" val="3255115357"/>
-                  </a:ext>
-                </a:extLst>
-              </a:tr>
-              <a:tr h="371078">
-                <a:tc>
-                  <a:txBody>
-                    <a:bodyPr/>
-                    <a:lstStyle/>
-                    <a:p>
-                      <a:endParaRPr lang="en-US" sz="1800"/>
-                    </a:p>
-                  </a:txBody>
-                  <a:tcPr marL="91434" marR="91434" marT="45749" marB="45749">
-                    <a:lnL w="12700" cap="flat" cmpd="sng" algn="ctr">
-                      <a:solidFill>
-                        <a:schemeClr val="tx1"/>
-                      </a:solidFill>
-                      <a:prstDash val="solid"/>
-                      <a:round/>
-                      <a:headEnd type="none" w="med" len="med"/>
-                      <a:tailEnd type="none" w="med" len="med"/>
-                    </a:lnL>
-                    <a:lnR w="12700" cap="flat" cmpd="sng" algn="ctr">
-                      <a:solidFill>
-                        <a:schemeClr val="tx1"/>
-                      </a:solidFill>
-                      <a:prstDash val="solid"/>
-                      <a:round/>
-                      <a:headEnd type="none" w="med" len="med"/>
-                      <a:tailEnd type="none" w="med" len="med"/>
-                    </a:lnR>
-                    <a:lnT w="12700" cap="flat" cmpd="sng" algn="ctr">
-                      <a:solidFill>
-                        <a:schemeClr val="tx1"/>
-                      </a:solidFill>
-                      <a:prstDash val="solid"/>
-                      <a:round/>
-                      <a:headEnd type="none" w="med" len="med"/>
-                      <a:tailEnd type="none" w="med" len="med"/>
-                    </a:lnT>
-                    <a:lnB w="12700" cap="flat" cmpd="sng" algn="ctr">
-                      <a:solidFill>
-                        <a:schemeClr val="tx1"/>
-                      </a:solidFill>
-                      <a:prstDash val="solid"/>
-                      <a:round/>
-                      <a:headEnd type="none" w="med" len="med"/>
-                      <a:tailEnd type="none" w="med" len="med"/>
-                    </a:lnB>
-                    <a:noFill/>
-                  </a:tcPr>
-                </a:tc>
-                <a:tc>
-                  <a:txBody>
-                    <a:bodyPr/>
-                    <a:lstStyle/>
-                    <a:p>
-                      <a:endParaRPr lang="en-US" sz="1800" dirty="0"/>
-                    </a:p>
-                  </a:txBody>
-                  <a:tcPr marL="91434" marR="91434" marT="45749" marB="45749">
-                    <a:lnL w="12700" cap="flat" cmpd="sng" algn="ctr">
-                      <a:solidFill>
-                        <a:schemeClr val="tx1"/>
-                      </a:solidFill>
-                      <a:prstDash val="solid"/>
-                      <a:round/>
-                      <a:headEnd type="none" w="med" len="med"/>
-                      <a:tailEnd type="none" w="med" len="med"/>
-                    </a:lnL>
-                    <a:lnR w="12700" cap="flat" cmpd="sng" algn="ctr">
-                      <a:solidFill>
-                        <a:schemeClr val="tx1"/>
-                      </a:solidFill>
-                      <a:prstDash val="solid"/>
-                      <a:round/>
-                      <a:headEnd type="none" w="med" len="med"/>
-                      <a:tailEnd type="none" w="med" len="med"/>
-                    </a:lnR>
-                    <a:lnT w="12700" cap="flat" cmpd="sng" algn="ctr">
-                      <a:solidFill>
-                        <a:schemeClr val="tx1"/>
-                      </a:solidFill>
-                      <a:prstDash val="solid"/>
-                      <a:round/>
-                      <a:headEnd type="none" w="med" len="med"/>
-                      <a:tailEnd type="none" w="med" len="med"/>
-                    </a:lnT>
-                    <a:lnB w="12700" cap="flat" cmpd="sng" algn="ctr">
-                      <a:solidFill>
-                        <a:schemeClr val="tx1"/>
-                      </a:solidFill>
-                      <a:prstDash val="solid"/>
-                      <a:round/>
-                      <a:headEnd type="none" w="med" len="med"/>
-                      <a:tailEnd type="none" w="med" len="med"/>
-                    </a:lnB>
-                    <a:noFill/>
-                  </a:tcPr>
-                </a:tc>
-                <a:extLst>
-                  <a:ext uri="{0D108BD9-81ED-4DB2-BD59-A6C34878D82A}">
-                    <a16:rowId xmlns:a16="http://schemas.microsoft.com/office/drawing/2014/main" val="2318133102"/>
-                  </a:ext>
-                </a:extLst>
-              </a:tr>
-            </a:tbl>
-          </a:graphicData>
-        </a:graphic>
-      </p:graphicFrame>
       <p:sp>
         <p:nvSpPr>
           <p:cNvPr id="7" name="TextBox 6">
@@ -11529,7 +10337,7 @@
         </p:nvSpPr>
         <p:spPr>
           <a:xfrm>
-            <a:off x="1452563" y="2808288"/>
+            <a:off x="868363" y="2562757"/>
             <a:ext cx="7062787" cy="3368675"/>
           </a:xfrm>
         </p:spPr>
@@ -11546,7 +10354,7 @@
               </a:spcAft>
             </a:pPr>
             <a:r>
-              <a:rPr sz="1600" b="1" i="0">
+              <a:rPr sz="1600" b="1" i="0" dirty="0">
                 <a:solidFill>
                   <a:srgbClr val="761D3E"/>
                 </a:solidFill>
@@ -11561,7 +10369,7 @@
               </a:spcBef>
             </a:pPr>
             <a:r>
-              <a:rPr sz="1500" b="0" i="0">
+              <a:rPr sz="1500" b="0" i="0" dirty="0">
                 <a:solidFill>
                   <a:srgbClr val="1A1A1A"/>
                 </a:solidFill>
@@ -11576,7 +10384,7 @@
               </a:spcBef>
             </a:pPr>
             <a:r>
-              <a:rPr sz="1500" b="0" i="0">
+              <a:rPr sz="1500" b="0" i="0" dirty="0">
                 <a:solidFill>
                   <a:srgbClr val="1A1A1A"/>
                 </a:solidFill>
@@ -11591,93 +10399,49 @@
               </a:spcBef>
             </a:pPr>
             <a:r>
-              <a:rPr sz="1500" b="0" i="0">
+              <a:rPr sz="1500" b="0" i="0" dirty="0">
                 <a:solidFill>
                   <a:srgbClr val="1A1A1A"/>
                 </a:solidFill>
               </a:rPr>
-              <a:t>Payment Gateway (External) — processes payments, sends webhook callbacks to HomeLodge</a:t>
-            </a:r>
-          </a:p>
-          <a:p>
-            <a:pPr lvl="1">
-              <a:spcBef>
-                <a:spcPts val="300"/>
-              </a:spcBef>
-            </a:pPr>
-            <a:r>
-              <a:rPr sz="1500" b="0" i="0">
+              <a:t>Payment Gateway (External) — processes payments, sends webhook callbacks to </a:t>
+            </a:r>
+            <a:r>
+              <a:rPr sz="1500" b="0" i="0" dirty="0" err="1">
                 <a:solidFill>
                   <a:srgbClr val="1A1A1A"/>
                 </a:solidFill>
               </a:rPr>
-              <a:t>Google Calendar API (External) — receives booking events upon confirmation</a:t>
-            </a:r>
-          </a:p>
-          <a:p>
-            <a:pPr>
-              <a:spcBef>
-                <a:spcPts val="300"/>
-              </a:spcBef>
-            </a:pPr>
-            <a:endParaRPr sz="1500" b="0" i="0">
+              <a:t>HomeLodge</a:t>
+            </a:r>
+            <a:endParaRPr sz="1500" b="0" i="0" dirty="0">
               <a:solidFill>
                 <a:srgbClr val="1A1A1A"/>
               </a:solidFill>
             </a:endParaRPr>
           </a:p>
           <a:p>
+            <a:pPr lvl="1">
+              <a:spcBef>
+                <a:spcPts val="300"/>
+              </a:spcBef>
+            </a:pPr>
+            <a:r>
+              <a:rPr sz="1500" b="0" i="0" dirty="0">
+                <a:solidFill>
+                  <a:srgbClr val="1A1A1A"/>
+                </a:solidFill>
+              </a:rPr>
+              <a:t>Google Calendar API (External) — receives booking events upon confirmation</a:t>
+            </a:r>
+          </a:p>
+          <a:p>
             <a:pPr>
               <a:spcBef>
                 <a:spcPts val="300"/>
               </a:spcBef>
             </a:pPr>
-            <a:r>
-              <a:rPr sz="1600" b="1" i="0">
-                <a:solidFill>
-                  <a:srgbClr val="761D3E"/>
-                </a:solidFill>
-              </a:rPr>
-              <a:t>12 Modules  |  47 Use Cases  |  All traced to URS and PRD requirements</a:t>
-            </a:r>
-          </a:p>
-          <a:p>
-            <a:pPr lvl="1">
-              <a:spcBef>
-                <a:spcPts val="300"/>
-              </a:spcBef>
-            </a:pPr>
-            <a:r>
-              <a:rPr sz="1500" b="0" i="0">
-                <a:solidFill>
-                  <a:srgbClr val="1A1A1A"/>
-                </a:solidFill>
-              </a:rPr>
-              <a:t>Authentication, Homestay Management, Booking, Payment, Notification, Chat</a:t>
-            </a:r>
-          </a:p>
-          <a:p>
-            <a:pPr lvl="1">
-              <a:spcBef>
-                <a:spcPts val="300"/>
-              </a:spcBef>
-            </a:pPr>
-            <a:r>
-              <a:rPr sz="1500" b="0" i="0">
-                <a:solidFill>
-                  <a:srgbClr val="1A1A1A"/>
-                </a:solidFill>
-              </a:rPr>
-              <a:t>User Management, Role &amp; Permission, System Settings, Audit Logs, QR Code, Reporting &amp; Analytics</a:t>
-            </a:r>
-          </a:p>
-          <a:p>
-            <a:pPr>
-              <a:spcBef>
-                <a:spcPts val="300"/>
-              </a:spcBef>
-            </a:pPr>
-            <a:endParaRPr sz="1500" b="0" i="0">
+            <a:endParaRPr sz="1500" b="0" i="0" dirty="0">
               <a:solidFill>
                 <a:srgbClr val="1A1A1A"/>
               </a:solidFill>
@@ -11690,7 +10454,64 @@
               </a:spcBef>
             </a:pPr>
             <a:r>
-              <a:rPr sz="1400" b="0" i="0">
+              <a:rPr sz="1600" b="1" i="0" dirty="0">
+                <a:solidFill>
+                  <a:srgbClr val="761D3E"/>
+                </a:solidFill>
+              </a:rPr>
+              <a:t>12 Modules  |  47 Use Cases  |  All traced to URS and PRD requirements</a:t>
+            </a:r>
+          </a:p>
+          <a:p>
+            <a:pPr lvl="1">
+              <a:spcBef>
+                <a:spcPts val="300"/>
+              </a:spcBef>
+            </a:pPr>
+            <a:r>
+              <a:rPr sz="1500" b="0" i="0" dirty="0">
+                <a:solidFill>
+                  <a:srgbClr val="1A1A1A"/>
+                </a:solidFill>
+              </a:rPr>
+              <a:t>Authentication, Homestay Management, Booking, Payment, Notification, Chat</a:t>
+            </a:r>
+          </a:p>
+          <a:p>
+            <a:pPr lvl="1">
+              <a:spcBef>
+                <a:spcPts val="300"/>
+              </a:spcBef>
+            </a:pPr>
+            <a:r>
+              <a:rPr sz="1500" b="0" i="0" dirty="0">
+                <a:solidFill>
+                  <a:srgbClr val="1A1A1A"/>
+                </a:solidFill>
+              </a:rPr>
+              <a:t>User Management, Role &amp; Permission, System Settings, Audit Logs, QR Code, Reporting &amp; Analytics</a:t>
+            </a:r>
+          </a:p>
+          <a:p>
+            <a:pPr>
+              <a:spcBef>
+                <a:spcPts val="300"/>
+              </a:spcBef>
+            </a:pPr>
+            <a:endParaRPr sz="1500" b="0" i="0" dirty="0">
+              <a:solidFill>
+                <a:srgbClr val="1A1A1A"/>
+              </a:solidFill>
+            </a:endParaRPr>
+          </a:p>
+          <a:p>
+            <a:pPr>
+              <a:spcBef>
+                <a:spcPts val="300"/>
+              </a:spcBef>
+            </a:pPr>
+            <a:r>
+              <a:rPr sz="1400" b="0" i="0" dirty="0">
                 <a:solidFill>
                   <a:srgbClr val="555555"/>
                 </a:solidFill>
@@ -11716,7 +10537,7 @@
         </p:nvSpPr>
         <p:spPr bwMode="auto">
           <a:xfrm>
-            <a:off x="1452562" y="1657350"/>
+            <a:off x="868362" y="1411819"/>
             <a:ext cx="7062787" cy="1038225"/>
           </a:xfrm>
           <a:prstGeom prst="rect">
@@ -13949,7 +12770,23 @@
                   <a:srgbClr val="1A1A1A"/>
                 </a:solidFill>
               </a:rPr>
-              <a:t>Implement all 11 modules in dependency order using Laravel 1</a:t>
+              <a:t>Implement all 1</a:t>
+            </a:r>
+            <a:r>
+              <a:rPr lang="en-MY" sz="1400" b="0" i="0" dirty="0">
+                <a:solidFill>
+                  <a:srgbClr val="1A1A1A"/>
+                </a:solidFill>
+              </a:rPr>
+              <a:t>2</a:t>
+            </a:r>
+            <a:r>
+              <a:rPr sz="1400" b="0" i="0" dirty="0">
+                <a:solidFill>
+                  <a:srgbClr val="1A1A1A"/>
+                </a:solidFill>
+              </a:rPr>
+              <a:t> modules in dependency order using Laravel 1</a:t>
             </a:r>
             <a:r>
               <a:rPr lang="en-MY" sz="1400" b="0" i="0" dirty="0">
@@ -14708,12 +13545,28 @@
               </a:spcAft>
             </a:pPr>
             <a:r>
-              <a:rPr sz="1600" b="1" i="0">
+              <a:rPr sz="1600" b="1" i="0" dirty="0">
                 <a:solidFill>
                   <a:srgbClr val="761D3E"/>
                 </a:solidFill>
               </a:rPr>
-              <a:t>Problems that led to HomeLodge:</a:t>
+              <a:t>Problems that led to </a:t>
+            </a:r>
+            <a:r>
+              <a:rPr sz="1600" b="1" i="0" dirty="0" err="1">
+                <a:solidFill>
+                  <a:srgbClr val="761D3E"/>
+                </a:solidFill>
+              </a:rPr>
+              <a:t>HomeLodge</a:t>
+            </a:r>
+            <a:r>
+              <a:rPr sz="1600" b="1" i="0" dirty="0">
+                <a:solidFill>
+                  <a:srgbClr val="761D3E"/>
+                </a:solidFill>
+              </a:rPr>
+              <a:t>:</a:t>
             </a:r>
           </a:p>
           <a:p>
@@ -14723,7 +13576,7 @@
               </a:spcBef>
             </a:pPr>
             <a:r>
-              <a:rPr sz="1500" b="0" i="0">
+              <a:rPr sz="1500" b="0" i="0" dirty="0">
                 <a:solidFill>
                   <a:srgbClr val="1A1A1A"/>
                 </a:solidFill>
@@ -14737,7 +13590,7 @@
                 <a:spcPts val="300"/>
               </a:spcBef>
             </a:pPr>
-            <a:endParaRPr sz="1500" b="0" i="0">
+            <a:endParaRPr sz="1500" b="0" i="0" dirty="0">
               <a:solidFill>
                 <a:srgbClr val="1A1A1A"/>
               </a:solidFill>
@@ -14750,7 +13603,7 @@
               </a:spcBef>
             </a:pPr>
             <a:r>
-              <a:rPr sz="1600" b="1" i="0">
+              <a:rPr sz="1600" b="1" i="0" dirty="0">
                 <a:solidFill>
                   <a:srgbClr val="761D3E"/>
                 </a:solidFill>
@@ -14765,7 +13618,7 @@
               </a:spcBef>
             </a:pPr>
             <a:r>
-              <a:rPr sz="1500" b="0" i="0">
+              <a:rPr sz="1500" b="0" i="0" dirty="0">
                 <a:solidFill>
                   <a:srgbClr val="1A1A1A"/>
                 </a:solidFill>
@@ -14780,7 +13633,7 @@
               </a:spcBef>
             </a:pPr>
             <a:r>
-              <a:rPr sz="1500" b="0" i="0">
+              <a:rPr sz="1500" b="0" i="0" dirty="0">
                 <a:solidFill>
                   <a:srgbClr val="1A1A1A"/>
                 </a:solidFill>
@@ -14794,7 +13647,7 @@
                 <a:spcPts val="300"/>
               </a:spcBef>
             </a:pPr>
-            <a:endParaRPr sz="1500" b="0" i="0">
+            <a:endParaRPr sz="1500" b="0" i="0" dirty="0">
               <a:solidFill>
                 <a:srgbClr val="1A1A1A"/>
               </a:solidFill>
@@ -14807,7 +13660,7 @@
               </a:spcBef>
             </a:pPr>
             <a:r>
-              <a:rPr sz="1600" b="1" i="0">
+              <a:rPr sz="1600" b="1" i="0" dirty="0">
                 <a:solidFill>
                   <a:srgbClr val="761D3E"/>
                 </a:solidFill>
@@ -14822,7 +13675,7 @@
               </a:spcBef>
             </a:pPr>
             <a:r>
-              <a:rPr sz="1500" b="0" i="0">
+              <a:rPr sz="1500" b="0" i="0" dirty="0">
                 <a:solidFill>
                   <a:srgbClr val="1A1A1A"/>
                 </a:solidFill>
@@ -14837,7 +13690,7 @@
               </a:spcBef>
             </a:pPr>
             <a:r>
-              <a:rPr sz="1500" b="0" i="0">
+              <a:rPr sz="1500" b="0" i="0" dirty="0">
                 <a:solidFill>
                   <a:srgbClr val="1A1A1A"/>
                 </a:solidFill>
@@ -14852,7 +13705,7 @@
               </a:spcBef>
             </a:pPr>
             <a:r>
-              <a:rPr sz="1500" b="0" i="0">
+              <a:rPr sz="1500" b="0" i="0" dirty="0">
                 <a:solidFill>
                   <a:srgbClr val="1A1A1A"/>
                 </a:solidFill>
@@ -14867,7 +13720,7 @@
               </a:spcBef>
             </a:pPr>
             <a:r>
-              <a:rPr sz="1500" b="0" i="0">
+              <a:rPr sz="1500" b="0" i="0" dirty="0">
                 <a:solidFill>
                   <a:srgbClr val="1A1A1A"/>
                 </a:solidFill>
@@ -14881,7 +13734,7 @@
                 <a:spcPts val="300"/>
               </a:spcBef>
             </a:pPr>
-            <a:endParaRPr sz="1500" b="0" i="0">
+            <a:endParaRPr sz="1500" b="0" i="0" dirty="0">
               <a:solidFill>
                 <a:srgbClr val="1A1A1A"/>
               </a:solidFill>
@@ -14894,12 +13747,28 @@
               </a:spcBef>
             </a:pPr>
             <a:r>
-              <a:rPr sz="1600" b="1" i="0">
+              <a:rPr sz="1600" b="1" i="0" dirty="0">
                 <a:solidFill>
                   <a:srgbClr val="761D3E"/>
                 </a:solidFill>
               </a:rPr>
-              <a:t>PSM II will implement, test, and deploy HomeLodge.</a:t>
+              <a:t>PSM II will implement, test, and deploy </a:t>
+            </a:r>
+            <a:r>
+              <a:rPr sz="1600" b="1" i="0" dirty="0" err="1">
+                <a:solidFill>
+                  <a:srgbClr val="761D3E"/>
+                </a:solidFill>
+              </a:rPr>
+              <a:t>HomeLodge</a:t>
+            </a:r>
+            <a:r>
+              <a:rPr sz="1600" b="1" i="0" dirty="0">
+                <a:solidFill>
+                  <a:srgbClr val="761D3E"/>
+                </a:solidFill>
+              </a:rPr>
+              <a:t>.</a:t>
             </a:r>
           </a:p>
         </p:txBody>
@@ -17414,23 +16283,22 @@
         </p:nvSpPr>
         <p:spPr>
           <a:xfrm>
-            <a:off x="1470025" y="1825625"/>
-            <a:ext cx="7045325" cy="4351338"/>
+            <a:off x="381001" y="1825625"/>
+            <a:ext cx="8134350" cy="4351338"/>
           </a:xfrm>
         </p:spPr>
         <p:txBody>
           <a:bodyPr wrap="square"/>
           <a:lstStyle/>
           <a:p>
-            <a:pPr marL="571500" indent="-571500" eaLnBrk="1" hangingPunct="1">
+            <a:pPr marL="0" indent="0" eaLnBrk="1" hangingPunct="1">
               <a:spcBef>
                 <a:spcPts val="300"/>
               </a:spcBef>
               <a:spcAft>
                 <a:spcPts val="1000"/>
               </a:spcAft>
-              <a:buFont typeface="+mj-lt"/>
-              <a:buAutoNum type="romanUcPeriod"/>
+              <a:buNone/>
             </a:pPr>
             <a:r>
               <a:rPr sz="1600" b="0" i="0" dirty="0">
@@ -19022,17 +17890,10 @@
                 <a:ea typeface="Microsoft Sans Serif" panose="020B0604020202020204" pitchFamily="34" charset="0"/>
                 <a:cs typeface="Microsoft Sans Serif" panose="020B0604020202020204" pitchFamily="34" charset="0"/>
               </a:rPr>
-              <a:t>Operates in English only; multiple units under one administrator account</a:t>
-            </a:r>
-          </a:p>
-          <a:p>
-            <a:pPr lvl="1">
-              <a:spcBef>
-                <a:spcPts val="300"/>
-              </a:spcBef>
-            </a:pPr>
-            <a:r>
-              <a:rPr sz="1600" b="0" i="0" dirty="0">
+              <a:t>Operates in English only; multiple units under</a:t>
+            </a:r>
+            <a:r>
+              <a:rPr lang="en-MY" sz="1600" b="0" i="0" dirty="0">
                 <a:solidFill>
                   <a:srgbClr val="1A1A1A"/>
                 </a:solidFill>
@@ -19040,15 +17901,8 @@
                 <a:ea typeface="Microsoft Sans Serif" panose="020B0604020202020204" pitchFamily="34" charset="0"/>
                 <a:cs typeface="Microsoft Sans Serif" panose="020B0604020202020204" pitchFamily="34" charset="0"/>
               </a:rPr>
-              <a:t>11 modules: Authentication, Homestay Management, Booking, Payment, Notification,</a:t>
-            </a:r>
-          </a:p>
-          <a:p>
-            <a:pPr lvl="1">
-              <a:spcBef>
-                <a:spcPts val="300"/>
-              </a:spcBef>
-            </a:pPr>
+              <a:t> multiple</a:t>
+            </a:r>
             <a:r>
               <a:rPr sz="1600" b="0" i="0" dirty="0">
                 <a:solidFill>
@@ -19058,8 +17912,130 @@
                 <a:ea typeface="Microsoft Sans Serif" panose="020B0604020202020204" pitchFamily="34" charset="0"/>
                 <a:cs typeface="Microsoft Sans Serif" panose="020B0604020202020204" pitchFamily="34" charset="0"/>
               </a:rPr>
-              <a:t>Chat, User Management, Role &amp; Permission, System Settings, Audit Logs, QR Code Door Access</a:t>
-            </a:r>
+              <a:t> administrator account</a:t>
+            </a:r>
+            <a:r>
+              <a:rPr lang="en-MY" sz="1600" b="0" i="0" dirty="0">
+                <a:solidFill>
+                  <a:srgbClr val="1A1A1A"/>
+                </a:solidFill>
+                <a:latin typeface="Microsoft Sans Serif" panose="020B0604020202020204" pitchFamily="34" charset="0"/>
+                <a:ea typeface="Microsoft Sans Serif" panose="020B0604020202020204" pitchFamily="34" charset="0"/>
+                <a:cs typeface="Microsoft Sans Serif" panose="020B0604020202020204" pitchFamily="34" charset="0"/>
+              </a:rPr>
+              <a:t>s</a:t>
+            </a:r>
+            <a:endParaRPr sz="1600" b="0" i="0" dirty="0">
+              <a:solidFill>
+                <a:srgbClr val="1A1A1A"/>
+              </a:solidFill>
+              <a:latin typeface="Microsoft Sans Serif" panose="020B0604020202020204" pitchFamily="34" charset="0"/>
+              <a:ea typeface="Microsoft Sans Serif" panose="020B0604020202020204" pitchFamily="34" charset="0"/>
+              <a:cs typeface="Microsoft Sans Serif" panose="020B0604020202020204" pitchFamily="34" charset="0"/>
+            </a:endParaRPr>
+          </a:p>
+          <a:p>
+            <a:pPr lvl="1">
+              <a:spcBef>
+                <a:spcPts val="300"/>
+              </a:spcBef>
+            </a:pPr>
+            <a:r>
+              <a:rPr sz="1600" b="0" i="0" dirty="0">
+                <a:solidFill>
+                  <a:srgbClr val="1A1A1A"/>
+                </a:solidFill>
+                <a:latin typeface="Microsoft Sans Serif" panose="020B0604020202020204" pitchFamily="34" charset="0"/>
+                <a:ea typeface="Microsoft Sans Serif" panose="020B0604020202020204" pitchFamily="34" charset="0"/>
+                <a:cs typeface="Microsoft Sans Serif" panose="020B0604020202020204" pitchFamily="34" charset="0"/>
+              </a:rPr>
+              <a:t>1</a:t>
+            </a:r>
+            <a:r>
+              <a:rPr lang="en-MY" sz="1600" b="0" i="0" dirty="0">
+                <a:solidFill>
+                  <a:srgbClr val="1A1A1A"/>
+                </a:solidFill>
+                <a:latin typeface="Microsoft Sans Serif" panose="020B0604020202020204" pitchFamily="34" charset="0"/>
+                <a:ea typeface="Microsoft Sans Serif" panose="020B0604020202020204" pitchFamily="34" charset="0"/>
+                <a:cs typeface="Microsoft Sans Serif" panose="020B0604020202020204" pitchFamily="34" charset="0"/>
+              </a:rPr>
+              <a:t>2</a:t>
+            </a:r>
+            <a:r>
+              <a:rPr sz="1600" b="0" i="0" dirty="0">
+                <a:solidFill>
+                  <a:srgbClr val="1A1A1A"/>
+                </a:solidFill>
+                <a:latin typeface="Microsoft Sans Serif" panose="020B0604020202020204" pitchFamily="34" charset="0"/>
+                <a:ea typeface="Microsoft Sans Serif" panose="020B0604020202020204" pitchFamily="34" charset="0"/>
+                <a:cs typeface="Microsoft Sans Serif" panose="020B0604020202020204" pitchFamily="34" charset="0"/>
+              </a:rPr>
+              <a:t> modules: Authentication, Homestay Management, Booking, Payment, Notification,</a:t>
+            </a:r>
+            <a:r>
+              <a:rPr lang="en-MY" sz="1600" b="0" i="0" dirty="0">
+                <a:solidFill>
+                  <a:srgbClr val="1A1A1A"/>
+                </a:solidFill>
+                <a:latin typeface="Microsoft Sans Serif" panose="020B0604020202020204" pitchFamily="34" charset="0"/>
+                <a:ea typeface="Microsoft Sans Serif" panose="020B0604020202020204" pitchFamily="34" charset="0"/>
+                <a:cs typeface="Microsoft Sans Serif" panose="020B0604020202020204" pitchFamily="34" charset="0"/>
+              </a:rPr>
+              <a:t> </a:t>
+            </a:r>
+            <a:r>
+              <a:rPr sz="1600" b="0" i="0" dirty="0">
+                <a:solidFill>
+                  <a:srgbClr val="1A1A1A"/>
+                </a:solidFill>
+                <a:latin typeface="Microsoft Sans Serif" panose="020B0604020202020204" pitchFamily="34" charset="0"/>
+                <a:ea typeface="Microsoft Sans Serif" panose="020B0604020202020204" pitchFamily="34" charset="0"/>
+                <a:cs typeface="Microsoft Sans Serif" panose="020B0604020202020204" pitchFamily="34" charset="0"/>
+              </a:rPr>
+              <a:t>Chat, User</a:t>
+            </a:r>
+            <a:r>
+              <a:rPr lang="en-MY" sz="1600" b="0" i="0" dirty="0">
+                <a:solidFill>
+                  <a:srgbClr val="1A1A1A"/>
+                </a:solidFill>
+                <a:latin typeface="Microsoft Sans Serif" panose="020B0604020202020204" pitchFamily="34" charset="0"/>
+                <a:ea typeface="Microsoft Sans Serif" panose="020B0604020202020204" pitchFamily="34" charset="0"/>
+                <a:cs typeface="Microsoft Sans Serif" panose="020B0604020202020204" pitchFamily="34" charset="0"/>
+              </a:rPr>
+              <a:t> &amp; Access</a:t>
+            </a:r>
+            <a:r>
+              <a:rPr sz="1600" b="0" i="0" dirty="0">
+                <a:solidFill>
+                  <a:srgbClr val="1A1A1A"/>
+                </a:solidFill>
+                <a:latin typeface="Microsoft Sans Serif" panose="020B0604020202020204" pitchFamily="34" charset="0"/>
+                <a:ea typeface="Microsoft Sans Serif" panose="020B0604020202020204" pitchFamily="34" charset="0"/>
+                <a:cs typeface="Microsoft Sans Serif" panose="020B0604020202020204" pitchFamily="34" charset="0"/>
+              </a:rPr>
+              <a:t> Management, System Settings, Audit Logs, QR Code Door Access</a:t>
+            </a:r>
+            <a:r>
+              <a:rPr lang="en-MY" sz="1600" b="0" i="0" dirty="0">
+                <a:solidFill>
+                  <a:srgbClr val="1A1A1A"/>
+                </a:solidFill>
+                <a:latin typeface="Microsoft Sans Serif" panose="020B0604020202020204" pitchFamily="34" charset="0"/>
+                <a:ea typeface="Microsoft Sans Serif" panose="020B0604020202020204" pitchFamily="34" charset="0"/>
+                <a:cs typeface="Microsoft Sans Serif" panose="020B0604020202020204" pitchFamily="34" charset="0"/>
+              </a:rPr>
+              <a:t>, Reporting &amp; Analytics, and Guest Feedback</a:t>
+            </a:r>
+            <a:endParaRPr sz="1600" b="0" i="0" dirty="0">
+              <a:solidFill>
+                <a:srgbClr val="1A1A1A"/>
+              </a:solidFill>
+              <a:latin typeface="Microsoft Sans Serif" panose="020B0604020202020204" pitchFamily="34" charset="0"/>
+              <a:ea typeface="Microsoft Sans Serif" panose="020B0604020202020204" pitchFamily="34" charset="0"/>
+              <a:cs typeface="Microsoft Sans Serif" panose="020B0604020202020204" pitchFamily="34" charset="0"/>
+            </a:endParaRPr>
           </a:p>
           <a:p>
             <a:pPr lvl="1">
@@ -19714,7 +18690,7 @@
               </a:spcAft>
             </a:pPr>
             <a:r>
-              <a:rPr sz="1600" b="0" i="0">
+              <a:rPr sz="1600" b="0" i="0" dirty="0">
                 <a:solidFill>
                   <a:srgbClr val="1A1A1A"/>
                 </a:solidFill>
@@ -19728,7 +18704,7 @@
                 <a:spcPts val="300"/>
               </a:spcBef>
             </a:pPr>
-            <a:endParaRPr sz="1600" b="0" i="0">
+            <a:endParaRPr sz="1600" b="0" i="0" dirty="0">
               <a:solidFill>
                 <a:srgbClr val="1A1A1A"/>
               </a:solidFill>
@@ -19741,7 +18717,7 @@
               </a:spcBef>
             </a:pPr>
             <a:r>
-              <a:rPr sz="1500" b="1" i="0">
+              <a:rPr sz="1500" b="1" i="0" dirty="0">
                 <a:solidFill>
                   <a:srgbClr val="761D3E"/>
                 </a:solidFill>
@@ -19756,12 +18732,20 @@
               </a:spcBef>
             </a:pPr>
             <a:r>
-              <a:rPr sz="1500" b="0" i="0">
+              <a:rPr sz="1500" b="0" i="0" dirty="0" err="1">
                 <a:solidFill>
                   <a:srgbClr val="1A1A1A"/>
                 </a:solidFill>
               </a:rPr>
-              <a:t>Centralised availability calendar, online payment processing, in-app messaging, host dashboard</a:t>
+              <a:t>Centralised</a:t>
+            </a:r>
+            <a:r>
+              <a:rPr sz="1500" b="0" i="0" dirty="0">
+                <a:solidFill>
+                  <a:srgbClr val="1A1A1A"/>
+                </a:solidFill>
+              </a:rPr>
+              <a:t> availability calendar, online payment processing, in-app messaging, host dashboard</a:t>
             </a:r>
           </a:p>
           <a:p>
@@ -19770,7 +18754,7 @@
                 <a:spcPts val="300"/>
               </a:spcBef>
             </a:pPr>
-            <a:endParaRPr sz="1500" b="0" i="0">
+            <a:endParaRPr sz="1500" b="0" i="0" dirty="0">
               <a:solidFill>
                 <a:srgbClr val="1A1A1A"/>
               </a:solidFill>
@@ -19783,7 +18767,7 @@
               </a:spcBef>
             </a:pPr>
             <a:r>
-              <a:rPr sz="1500" b="1" i="0">
+              <a:rPr sz="1500" b="1" i="0" dirty="0">
                 <a:solidFill>
                   <a:srgbClr val="761D3E"/>
                 </a:solidFill>
@@ -19798,7 +18782,7 @@
               </a:spcBef>
             </a:pPr>
             <a:r>
-              <a:rPr sz="1500" b="0" i="0">
+              <a:rPr sz="1500" b="0" i="0" dirty="0">
                 <a:solidFill>
                   <a:srgbClr val="1A1A1A"/>
                 </a:solidFill>
@@ -19813,7 +18797,7 @@
               </a:spcBef>
             </a:pPr>
             <a:r>
-              <a:rPr sz="1500" b="0" i="0">
+              <a:rPr sz="1500" b="0" i="0" dirty="0">
                 <a:solidFill>
                   <a:srgbClr val="1A1A1A"/>
                 </a:solidFill>
@@ -19828,7 +18812,7 @@
               </a:spcBef>
             </a:pPr>
             <a:r>
-              <a:rPr sz="1500" b="0" i="0">
+              <a:rPr sz="1500" b="0" i="0" dirty="0">
                 <a:solidFill>
                   <a:srgbClr val="1A1A1A"/>
                 </a:solidFill>
@@ -19843,7 +18827,7 @@
               </a:spcBef>
             </a:pPr>
             <a:r>
-              <a:rPr sz="1500" b="0" i="0">
+              <a:rPr sz="1500" b="0" i="0" dirty="0">
                 <a:solidFill>
                   <a:srgbClr val="1A1A1A"/>
                 </a:solidFill>
@@ -19858,7 +18842,7 @@
               </a:spcBef>
             </a:pPr>
             <a:r>
-              <a:rPr sz="1500" b="0" i="0">
+              <a:rPr sz="1500" b="0" i="0" dirty="0">
                 <a:solidFill>
                   <a:srgbClr val="1A1A1A"/>
                 </a:solidFill>
@@ -20628,7 +19612,7 @@
               </a:spcAft>
             </a:pPr>
             <a:r>
-              <a:rPr sz="1600" b="0" i="0">
+              <a:rPr sz="1600" b="0" i="0" dirty="0">
                 <a:solidFill>
                   <a:srgbClr val="1A1A1A"/>
                 </a:solidFill>
@@ -20642,7 +19626,7 @@
                 <a:spcPts val="300"/>
               </a:spcBef>
             </a:pPr>
-            <a:endParaRPr sz="1600" b="0" i="0">
+            <a:endParaRPr sz="1600" b="0" i="0" dirty="0">
               <a:solidFill>
                 <a:srgbClr val="1A1A1A"/>
               </a:solidFill>
@@ -20655,7 +19639,7 @@
               </a:spcBef>
             </a:pPr>
             <a:r>
-              <a:rPr sz="1500" b="1" i="0">
+              <a:rPr sz="1500" b="1" i="0" dirty="0">
                 <a:solidFill>
                   <a:srgbClr val="761D3E"/>
                 </a:solidFill>
@@ -20670,21 +19654,22 @@
               </a:spcBef>
             </a:pPr>
             <a:r>
-              <a:rPr sz="1500" b="0" i="0">
+              <a:rPr sz="1500" b="0" i="0" dirty="0">
                 <a:solidFill>
                   <a:srgbClr val="1A1A1A"/>
                 </a:solidFill>
               </a:rPr>
-              <a:t>Availability management, incoming booking view, guest communication, analytics, loyalty programme</a:t>
-            </a:r>
-          </a:p>
-          <a:p>
-            <a:pPr>
-              <a:spcBef>
-                <a:spcPts val="300"/>
-              </a:spcBef>
-            </a:pPr>
-            <a:endParaRPr sz="1500" b="0" i="0">
+              <a:t>Availability management, incoming booking view, guest communication, analytics, loyalty </a:t>
+            </a:r>
+            <a:r>
+              <a:rPr sz="1500" b="0" i="0" dirty="0" err="1">
+                <a:solidFill>
+                  <a:srgbClr val="1A1A1A"/>
+                </a:solidFill>
+              </a:rPr>
+              <a:t>programme</a:t>
+            </a:r>
+            <a:endParaRPr sz="1500" b="0" i="0" dirty="0">
               <a:solidFill>
                 <a:srgbClr val="1A1A1A"/>
               </a:solidFill>
@@ -20696,8 +19681,20 @@
                 <a:spcPts val="300"/>
               </a:spcBef>
             </a:pPr>
-            <a:r>
-              <a:rPr sz="1500" b="1" i="0">
+            <a:endParaRPr sz="1500" b="0" i="0" dirty="0">
+              <a:solidFill>
+                <a:srgbClr val="1A1A1A"/>
+              </a:solidFill>
+            </a:endParaRPr>
+          </a:p>
+          <a:p>
+            <a:pPr>
+              <a:spcBef>
+                <a:spcPts val="300"/>
+              </a:spcBef>
+            </a:pPr>
+            <a:r>
+              <a:rPr sz="1500" b="1" i="0" dirty="0">
                 <a:solidFill>
                   <a:srgbClr val="761D3E"/>
                 </a:solidFill>
@@ -20712,7 +19709,7 @@
               </a:spcBef>
             </a:pPr>
             <a:r>
-              <a:rPr sz="1500" b="0" i="0">
+              <a:rPr sz="1500" b="0" i="0" dirty="0">
                 <a:solidFill>
                   <a:srgbClr val="1A1A1A"/>
                 </a:solidFill>
@@ -20727,7 +19724,7 @@
               </a:spcBef>
             </a:pPr>
             <a:r>
-              <a:rPr sz="1500" b="0" i="0">
+              <a:rPr sz="1500" b="0" i="0" dirty="0">
                 <a:solidFill>
                   <a:srgbClr val="1A1A1A"/>
                 </a:solidFill>
@@ -20742,7 +19739,7 @@
               </a:spcBef>
             </a:pPr>
             <a:r>
-              <a:rPr sz="1500" b="0" i="0">
+              <a:rPr sz="1500" b="0" i="0" dirty="0">
                 <a:solidFill>
                   <a:srgbClr val="1A1A1A"/>
                 </a:solidFill>
@@ -20757,7 +19754,7 @@
               </a:spcBef>
             </a:pPr>
             <a:r>
-              <a:rPr sz="1500" b="0" i="0">
+              <a:rPr sz="1500" b="0" i="0" dirty="0">
                 <a:solidFill>
                   <a:srgbClr val="1A1A1A"/>
                 </a:solidFill>
@@ -21527,7 +20524,7 @@
               </a:spcAft>
             </a:pPr>
             <a:r>
-              <a:rPr sz="1600" b="0" i="0">
+              <a:rPr sz="1600" b="0" i="0" dirty="0">
                 <a:solidFill>
                   <a:srgbClr val="1A1A1A"/>
                 </a:solidFill>
@@ -21541,7 +20538,7 @@
                 <a:spcPts val="300"/>
               </a:spcBef>
             </a:pPr>
-            <a:endParaRPr sz="1600" b="0" i="0">
+            <a:endParaRPr sz="1600" b="0" i="0" dirty="0">
               <a:solidFill>
                 <a:srgbClr val="1A1A1A"/>
               </a:solidFill>
@@ -21554,7 +20551,7 @@
               </a:spcBef>
             </a:pPr>
             <a:r>
-              <a:rPr sz="1500" b="1" i="0">
+              <a:rPr sz="1500" b="1" i="0" dirty="0">
                 <a:solidFill>
                   <a:srgbClr val="761D3E"/>
                 </a:solidFill>
@@ -21569,12 +20566,20 @@
               </a:spcBef>
             </a:pPr>
             <a:r>
-              <a:rPr sz="1500" b="0" i="0">
+              <a:rPr sz="1500" b="0" i="0" dirty="0" err="1">
                 <a:solidFill>
                   <a:srgbClr val="1A1A1A"/>
                 </a:solidFill>
               </a:rPr>
-              <a:t>Localisation for Malaysian market: Bahasa Malaysia, FPX bank transfers, in-platform messaging</a:t>
+              <a:t>Localisation</a:t>
+            </a:r>
+            <a:r>
+              <a:rPr sz="1500" b="0" i="0" dirty="0">
+                <a:solidFill>
+                  <a:srgbClr val="1A1A1A"/>
+                </a:solidFill>
+              </a:rPr>
+              <a:t> for Malaysian market: Bahasa Malaysia, FPX bank transfers, in-platform messaging</a:t>
             </a:r>
           </a:p>
           <a:p>
@@ -21583,7 +20588,7 @@
                 <a:spcPts val="300"/>
               </a:spcBef>
             </a:pPr>
-            <a:endParaRPr sz="1500" b="0" i="0">
+            <a:endParaRPr sz="1500" b="0" i="0" dirty="0">
               <a:solidFill>
                 <a:srgbClr val="1A1A1A"/>
               </a:solidFill>
@@ -21596,7 +20601,7 @@
               </a:spcBef>
             </a:pPr>
             <a:r>
-              <a:rPr sz="1500" b="1" i="0">
+              <a:rPr sz="1500" b="1" i="0" dirty="0">
                 <a:solidFill>
                   <a:srgbClr val="761D3E"/>
                 </a:solidFill>
@@ -21611,7 +20616,7 @@
               </a:spcBef>
             </a:pPr>
             <a:r>
-              <a:rPr sz="1500" b="0" i="0">
+              <a:rPr sz="1500" b="0" i="0" dirty="0">
                 <a:solidFill>
                   <a:srgbClr val="1A1A1A"/>
                 </a:solidFill>
@@ -21626,7 +20631,7 @@
               </a:spcBef>
             </a:pPr>
             <a:r>
-              <a:rPr sz="1500" b="0" i="0">
+              <a:rPr sz="1500" b="0" i="0" dirty="0">
                 <a:solidFill>
                   <a:srgbClr val="1A1A1A"/>
                 </a:solidFill>
@@ -21641,7 +20646,7 @@
               </a:spcBef>
             </a:pPr>
             <a:r>
-              <a:rPr sz="1500" b="0" i="0">
+              <a:rPr sz="1500" b="0" i="0" dirty="0">
                 <a:solidFill>
                   <a:srgbClr val="1A1A1A"/>
                 </a:solidFill>
@@ -21656,7 +20661,7 @@
               </a:spcBef>
             </a:pPr>
             <a:r>
-              <a:rPr sz="1500" b="0" i="0">
+              <a:rPr sz="1500" b="0" i="0" dirty="0">
                 <a:solidFill>
                   <a:srgbClr val="1A1A1A"/>
                 </a:solidFill>
@@ -21888,7 +20893,7 @@
                 <a:latin typeface="Microsoft Sans Serif" panose="020B0604020202020204" pitchFamily="34" charset="0"/>
                 <a:cs typeface="Microsoft Sans Serif" panose="020B0604020202020204" pitchFamily="34" charset="0"/>
               </a:rPr>
-              <a:t>(c) System 3</a:t>
+              <a:t>(c) Agoda</a:t>
             </a:r>
           </a:p>
         </p:txBody>

</xml_diff>